<commit_message>
Update presentation to focus on research outcomes and continuous workflow
Updates pitch deck content and structure to emphasize researcher benefits, including a unified workflow, persistent context, and outcome-based feature descriptions, alongside technical modifications to Python scripts and metadata.

Replit-Commit-Author: Agent
Replit-Commit-Session-Id: b53fded6-c78f-4e6c-84d6-a0d930aa07e5
Replit-Commit-Checkpoint-Type: full_checkpoint
Replit-Commit-Event-Id: 92e37b1a-500b-4ff1-9cd9-0881c090fd5e
Replit-Commit-Screenshot-Url: https://storage.googleapis.com/screenshot-production-us-central1/8eaa45a3-5daf-4c6a-923e-29a09dc86423/b53fded6-c78f-4e6c-84d6-a0d930aa07e5/bUvVKzp
Replit-Helium-Checkpoint-Created: true
</commit_message>
<xml_diff>
--- a/Dynamo_AI_Pitch_Deck.pptx
+++ b/Dynamo_AI_Pitch_Deck.pptx
@@ -3456,7 +3456,7 @@
                 </a:solidFill>
                 <a:latin typeface="Calibri"/>
               </a:rPr>
-              <a:t>Built for India's 200,000+ PhD scholars, researchers and educators.</a:t>
+              <a:t>Built for researchers, scholars and educators.</a:t>
             </a:r>
           </a:p>
         </p:txBody>
@@ -3845,7 +3845,7 @@
         <p:spPr>
           <a:xfrm>
             <a:off x="365760" y="2423160"/>
-            <a:ext cx="2926080" cy="420624"/>
+            <a:ext cx="3840480" cy="420624"/>
           </a:xfrm>
           <a:prstGeom prst="rect">
             <a:avLst/>
@@ -3890,7 +3890,7 @@
         <p:spPr>
           <a:xfrm>
             <a:off x="438912" y="2514600"/>
-            <a:ext cx="2834640" cy="256032"/>
+            <a:ext cx="3749040" cy="256032"/>
           </a:xfrm>
           <a:prstGeom prst="rect">
             <a:avLst/>
@@ -3911,7 +3911,7 @@
                 </a:solidFill>
                 <a:latin typeface="Calibri"/>
               </a:rPr>
-              <a:t>Capability</a:t>
+              <a:t>Researcher Outcome</a:t>
             </a:r>
           </a:p>
         </p:txBody>
@@ -3924,8 +3924,8 @@
         </p:nvSpPr>
         <p:spPr>
           <a:xfrm>
-            <a:off x="3291840" y="2423160"/>
-            <a:ext cx="1463040" cy="420624"/>
+            <a:off x="4206240" y="2423160"/>
+            <a:ext cx="1645920" cy="420624"/>
           </a:xfrm>
           <a:prstGeom prst="rect">
             <a:avLst/>
@@ -3969,8 +3969,8 @@
         </p:nvSpPr>
         <p:spPr>
           <a:xfrm>
-            <a:off x="3364992" y="2514600"/>
-            <a:ext cx="1371600" cy="256032"/>
+            <a:off x="4279392" y="2514600"/>
+            <a:ext cx="1554480" cy="256032"/>
           </a:xfrm>
           <a:prstGeom prst="rect">
             <a:avLst/>
@@ -4004,8 +4004,8 @@
         </p:nvSpPr>
         <p:spPr>
           <a:xfrm>
-            <a:off x="4754880" y="2423160"/>
-            <a:ext cx="1463040" cy="420624"/>
+            <a:off x="5852160" y="2423160"/>
+            <a:ext cx="1645920" cy="420624"/>
           </a:xfrm>
           <a:prstGeom prst="rect">
             <a:avLst/>
@@ -4049,8 +4049,8 @@
         </p:nvSpPr>
         <p:spPr>
           <a:xfrm>
-            <a:off x="4828032" y="2514600"/>
-            <a:ext cx="1371600" cy="256032"/>
+            <a:off x="5925312" y="2514600"/>
+            <a:ext cx="1554480" cy="256032"/>
           </a:xfrm>
           <a:prstGeom prst="rect">
             <a:avLst/>
@@ -4084,8 +4084,8 @@
         </p:nvSpPr>
         <p:spPr>
           <a:xfrm>
-            <a:off x="6217920" y="2423160"/>
-            <a:ext cx="1463040" cy="420624"/>
+            <a:off x="7498080" y="2423160"/>
+            <a:ext cx="1645920" cy="420624"/>
           </a:xfrm>
           <a:prstGeom prst="rect">
             <a:avLst/>
@@ -4129,8 +4129,8 @@
         </p:nvSpPr>
         <p:spPr>
           <a:xfrm>
-            <a:off x="6291072" y="2514600"/>
-            <a:ext cx="1371600" cy="256032"/>
+            <a:off x="7571232" y="2514600"/>
+            <a:ext cx="1554480" cy="256032"/>
           </a:xfrm>
           <a:prstGeom prst="rect">
             <a:avLst/>
@@ -4151,7 +4151,7 @@
                 </a:solidFill>
                 <a:latin typeface="Calibri"/>
               </a:rPr>
-              <a:t>Elicit</a:t>
+              <a:t>Jenni</a:t>
             </a:r>
           </a:p>
         </p:txBody>
@@ -4164,8 +4164,8 @@
         </p:nvSpPr>
         <p:spPr>
           <a:xfrm>
-            <a:off x="7680960" y="2423160"/>
-            <a:ext cx="1463040" cy="420624"/>
+            <a:off x="9144000" y="2423160"/>
+            <a:ext cx="1783080" cy="420624"/>
           </a:xfrm>
           <a:prstGeom prst="rect">
             <a:avLst/>
@@ -4209,8 +4209,8 @@
         </p:nvSpPr>
         <p:spPr>
           <a:xfrm>
-            <a:off x="7754112" y="2514600"/>
-            <a:ext cx="1371600" cy="256032"/>
+            <a:off x="9217152" y="2514600"/>
+            <a:ext cx="1691639" cy="256032"/>
           </a:xfrm>
           <a:prstGeom prst="rect">
             <a:avLst/>
@@ -4231,7 +4231,7 @@
                 </a:solidFill>
                 <a:latin typeface="Calibri"/>
               </a:rPr>
-              <a:t>Jenni</a:t>
+              <a:t>⚡ Dynamo AI</a:t>
             </a:r>
           </a:p>
         </p:txBody>
@@ -4244,88 +4244,8 @@
         </p:nvSpPr>
         <p:spPr>
           <a:xfrm>
-            <a:off x="9144000" y="2423160"/>
-            <a:ext cx="1737360" cy="420624"/>
-          </a:xfrm>
-          <a:prstGeom prst="rect">
-            <a:avLst/>
-          </a:prstGeom>
-          <a:solidFill>
-            <a:srgbClr val="201900"/>
-          </a:solidFill>
-          <a:ln w="12700">
-            <a:solidFill>
-              <a:srgbClr val="252A40"/>
-            </a:solidFill>
-          </a:ln>
-        </p:spPr>
-        <p:style>
-          <a:lnRef idx="1">
-            <a:schemeClr val="accent1"/>
-          </a:lnRef>
-          <a:fillRef idx="3">
-            <a:schemeClr val="accent1"/>
-          </a:fillRef>
-          <a:effectRef idx="2">
-            <a:schemeClr val="accent1"/>
-          </a:effectRef>
-          <a:fontRef idx="minor">
-            <a:schemeClr val="lt1"/>
-          </a:fontRef>
-        </p:style>
-        <p:txBody>
-          <a:bodyPr rtlCol="0" anchor="ctr"/>
-          <a:lstStyle/>
-          <a:p>
-            <a:pPr algn="ctr"/>
-          </a:p>
-        </p:txBody>
-      </p:sp>
-      <p:sp>
-        <p:nvSpPr>
-          <p:cNvPr id="21" name="TextBox 20"/>
-          <p:cNvSpPr txBox="1"/>
-          <p:nvPr/>
-        </p:nvSpPr>
-        <p:spPr>
-          <a:xfrm>
-            <a:off x="9217152" y="2514600"/>
-            <a:ext cx="1645919" cy="256032"/>
-          </a:xfrm>
-          <a:prstGeom prst="rect">
-            <a:avLst/>
-          </a:prstGeom>
-          <a:noFill/>
-        </p:spPr>
-        <p:txBody>
-          <a:bodyPr wrap="square" lIns="45720" rIns="45720" tIns="18288" bIns="18288">
-            <a:spAutoFit/>
-          </a:bodyPr>
-          <a:lstStyle/>
-          <a:p>
-            <a:pPr algn="ctr"/>
-            <a:r>
-              <a:rPr sz="900" b="1">
-                <a:solidFill>
-                  <a:srgbClr val="FFC107"/>
-                </a:solidFill>
-                <a:latin typeface="Calibri"/>
-              </a:rPr>
-              <a:t>⚡ Dynamo AI</a:t>
-            </a:r>
-          </a:p>
-        </p:txBody>
-      </p:sp>
-      <p:sp>
-        <p:nvSpPr>
-          <p:cNvPr id="22" name="Rectangle 21"/>
-          <p:cNvSpPr/>
-          <p:nvPr/>
-        </p:nvSpPr>
-        <p:spPr>
-          <a:xfrm>
             <a:off x="365760" y="2843784"/>
-            <a:ext cx="2926080" cy="420624"/>
+            <a:ext cx="3840480" cy="420624"/>
           </a:xfrm>
           <a:prstGeom prst="rect">
             <a:avLst/>
@@ -4363,14 +4283,14 @@
       </p:sp>
       <p:sp>
         <p:nvSpPr>
-          <p:cNvPr id="23" name="TextBox 22"/>
+          <p:cNvPr id="21" name="TextBox 20"/>
           <p:cNvSpPr txBox="1"/>
           <p:nvPr/>
         </p:nvSpPr>
         <p:spPr>
           <a:xfrm>
             <a:off x="457200" y="2935224"/>
-            <a:ext cx="2788920" cy="256032"/>
+            <a:ext cx="3703320" cy="256032"/>
           </a:xfrm>
           <a:prstGeom prst="rect">
             <a:avLst/>
@@ -4391,21 +4311,21 @@
                 </a:solidFill>
                 <a:latin typeface="Calibri"/>
               </a:rPr>
-              <a:t>Research Search</a:t>
-            </a:r>
-          </a:p>
-        </p:txBody>
-      </p:sp>
-      <p:sp>
-        <p:nvSpPr>
-          <p:cNvPr id="24" name="Rectangle 23"/>
+              <a:t>Find evidence from research papers</a:t>
+            </a:r>
+          </a:p>
+        </p:txBody>
+      </p:sp>
+      <p:sp>
+        <p:nvSpPr>
+          <p:cNvPr id="22" name="Rectangle 21"/>
           <p:cNvSpPr/>
           <p:nvPr/>
         </p:nvSpPr>
         <p:spPr>
           <a:xfrm>
-            <a:off x="3291840" y="2843784"/>
-            <a:ext cx="1463040" cy="420624"/>
+            <a:off x="4206240" y="2843784"/>
+            <a:ext cx="1645920" cy="420624"/>
           </a:xfrm>
           <a:prstGeom prst="rect">
             <a:avLst/>
@@ -4443,14 +4363,14 @@
       </p:sp>
       <p:sp>
         <p:nvSpPr>
-          <p:cNvPr id="25" name="TextBox 24"/>
-          <p:cNvSpPr txBox="1"/>
-          <p:nvPr/>
-        </p:nvSpPr>
-        <p:spPr>
-          <a:xfrm>
-            <a:off x="3291840" y="2907792"/>
-            <a:ext cx="1463040" cy="292608"/>
+          <p:cNvPr id="23" name="TextBox 22"/>
+          <p:cNvSpPr txBox="1"/>
+          <p:nvPr/>
+        </p:nvSpPr>
+        <p:spPr>
+          <a:xfrm>
+            <a:off x="4206240" y="2907792"/>
+            <a:ext cx="1645920" cy="292608"/>
           </a:xfrm>
           <a:prstGeom prst="rect">
             <a:avLst/>
@@ -4478,14 +4398,14 @@
       </p:sp>
       <p:sp>
         <p:nvSpPr>
-          <p:cNvPr id="26" name="Rectangle 25"/>
+          <p:cNvPr id="24" name="Rectangle 23"/>
           <p:cNvSpPr/>
           <p:nvPr/>
         </p:nvSpPr>
         <p:spPr>
           <a:xfrm>
-            <a:off x="4754880" y="2843784"/>
-            <a:ext cx="1463040" cy="420624"/>
+            <a:off x="5852160" y="2843784"/>
+            <a:ext cx="1645920" cy="420624"/>
           </a:xfrm>
           <a:prstGeom prst="rect">
             <a:avLst/>
@@ -4523,14 +4443,14 @@
       </p:sp>
       <p:sp>
         <p:nvSpPr>
-          <p:cNvPr id="27" name="TextBox 26"/>
-          <p:cNvSpPr txBox="1"/>
-          <p:nvPr/>
-        </p:nvSpPr>
-        <p:spPr>
-          <a:xfrm>
-            <a:off x="4754880" y="2907792"/>
-            <a:ext cx="1463040" cy="292608"/>
+          <p:cNvPr id="25" name="TextBox 24"/>
+          <p:cNvSpPr txBox="1"/>
+          <p:nvPr/>
+        </p:nvSpPr>
+        <p:spPr>
+          <a:xfrm>
+            <a:off x="5852160" y="2907792"/>
+            <a:ext cx="1645920" cy="292608"/>
           </a:xfrm>
           <a:prstGeom prst="rect">
             <a:avLst/>
@@ -4558,14 +4478,14 @@
       </p:sp>
       <p:sp>
         <p:nvSpPr>
-          <p:cNvPr id="28" name="Rectangle 27"/>
+          <p:cNvPr id="26" name="Rectangle 25"/>
           <p:cNvSpPr/>
           <p:nvPr/>
         </p:nvSpPr>
         <p:spPr>
           <a:xfrm>
-            <a:off x="6217920" y="2843784"/>
-            <a:ext cx="1463040" cy="420624"/>
+            <a:off x="7498080" y="2843784"/>
+            <a:ext cx="1645920" cy="420624"/>
           </a:xfrm>
           <a:prstGeom prst="rect">
             <a:avLst/>
@@ -4603,14 +4523,14 @@
       </p:sp>
       <p:sp>
         <p:nvSpPr>
-          <p:cNvPr id="29" name="TextBox 28"/>
-          <p:cNvSpPr txBox="1"/>
-          <p:nvPr/>
-        </p:nvSpPr>
-        <p:spPr>
-          <a:xfrm>
-            <a:off x="6217920" y="2907792"/>
-            <a:ext cx="1463040" cy="292608"/>
+          <p:cNvPr id="27" name="TextBox 26"/>
+          <p:cNvSpPr txBox="1"/>
+          <p:nvPr/>
+        </p:nvSpPr>
+        <p:spPr>
+          <a:xfrm>
+            <a:off x="7498080" y="2907792"/>
+            <a:ext cx="1645920" cy="292608"/>
           </a:xfrm>
           <a:prstGeom prst="rect">
             <a:avLst/>
@@ -4627,25 +4547,25 @@
             <a:r>
               <a:rPr sz="1400" b="1">
                 <a:solidFill>
-                  <a:srgbClr val="22C55E"/>
-                </a:solidFill>
-                <a:latin typeface="Calibri"/>
-              </a:rPr>
-              <a:t>✓</a:t>
-            </a:r>
-          </a:p>
-        </p:txBody>
-      </p:sp>
-      <p:sp>
-        <p:nvSpPr>
-          <p:cNvPr id="30" name="Rectangle 29"/>
+                  <a:srgbClr val="EF4444"/>
+                </a:solidFill>
+                <a:latin typeface="Calibri"/>
+              </a:rPr>
+              <a:t>✗</a:t>
+            </a:r>
+          </a:p>
+        </p:txBody>
+      </p:sp>
+      <p:sp>
+        <p:nvSpPr>
+          <p:cNvPr id="28" name="Rectangle 27"/>
           <p:cNvSpPr/>
           <p:nvPr/>
         </p:nvSpPr>
         <p:spPr>
           <a:xfrm>
-            <a:off x="7680960" y="2843784"/>
-            <a:ext cx="1463040" cy="420624"/>
+            <a:off x="9144000" y="2843784"/>
+            <a:ext cx="1783080" cy="420624"/>
           </a:xfrm>
           <a:prstGeom prst="rect">
             <a:avLst/>
@@ -4683,14 +4603,14 @@
       </p:sp>
       <p:sp>
         <p:nvSpPr>
-          <p:cNvPr id="31" name="TextBox 30"/>
-          <p:cNvSpPr txBox="1"/>
-          <p:nvPr/>
-        </p:nvSpPr>
-        <p:spPr>
-          <a:xfrm>
-            <a:off x="7680960" y="2907792"/>
-            <a:ext cx="1463040" cy="292608"/>
+          <p:cNvPr id="29" name="TextBox 28"/>
+          <p:cNvSpPr txBox="1"/>
+          <p:nvPr/>
+        </p:nvSpPr>
+        <p:spPr>
+          <a:xfrm>
+            <a:off x="9144000" y="2907792"/>
+            <a:ext cx="1783080" cy="292608"/>
           </a:xfrm>
           <a:prstGeom prst="rect">
             <a:avLst/>
@@ -4707,105 +4627,25 @@
             <a:r>
               <a:rPr sz="1400" b="1">
                 <a:solidFill>
-                  <a:srgbClr val="EF4444"/>
-                </a:solidFill>
-                <a:latin typeface="Calibri"/>
-              </a:rPr>
-              <a:t>✗</a:t>
-            </a:r>
-          </a:p>
-        </p:txBody>
-      </p:sp>
-      <p:sp>
-        <p:nvSpPr>
-          <p:cNvPr id="32" name="Rectangle 31"/>
+                  <a:srgbClr val="22C55E"/>
+                </a:solidFill>
+                <a:latin typeface="Calibri"/>
+              </a:rPr>
+              <a:t>✓</a:t>
+            </a:r>
+          </a:p>
+        </p:txBody>
+      </p:sp>
+      <p:sp>
+        <p:nvSpPr>
+          <p:cNvPr id="30" name="Rectangle 29"/>
           <p:cNvSpPr/>
           <p:nvPr/>
         </p:nvSpPr>
         <p:spPr>
           <a:xfrm>
-            <a:off x="9144000" y="2843784"/>
-            <a:ext cx="1737360" cy="420624"/>
-          </a:xfrm>
-          <a:prstGeom prst="rect">
-            <a:avLst/>
-          </a:prstGeom>
-          <a:solidFill>
-            <a:srgbClr val="201900"/>
-          </a:solidFill>
-          <a:ln w="12700">
-            <a:solidFill>
-              <a:srgbClr val="252A40"/>
-            </a:solidFill>
-          </a:ln>
-        </p:spPr>
-        <p:style>
-          <a:lnRef idx="1">
-            <a:schemeClr val="accent1"/>
-          </a:lnRef>
-          <a:fillRef idx="3">
-            <a:schemeClr val="accent1"/>
-          </a:fillRef>
-          <a:effectRef idx="2">
-            <a:schemeClr val="accent1"/>
-          </a:effectRef>
-          <a:fontRef idx="minor">
-            <a:schemeClr val="lt1"/>
-          </a:fontRef>
-        </p:style>
-        <p:txBody>
-          <a:bodyPr rtlCol="0" anchor="ctr"/>
-          <a:lstStyle/>
-          <a:p>
-            <a:pPr algn="ctr"/>
-          </a:p>
-        </p:txBody>
-      </p:sp>
-      <p:sp>
-        <p:nvSpPr>
-          <p:cNvPr id="33" name="TextBox 32"/>
-          <p:cNvSpPr txBox="1"/>
-          <p:nvPr/>
-        </p:nvSpPr>
-        <p:spPr>
-          <a:xfrm>
-            <a:off x="9144000" y="2907792"/>
-            <a:ext cx="1737360" cy="292608"/>
-          </a:xfrm>
-          <a:prstGeom prst="rect">
-            <a:avLst/>
-          </a:prstGeom>
-          <a:noFill/>
-        </p:spPr>
-        <p:txBody>
-          <a:bodyPr wrap="square" lIns="45720" rIns="45720" tIns="18288" bIns="18288">
-            <a:spAutoFit/>
-          </a:bodyPr>
-          <a:lstStyle/>
-          <a:p>
-            <a:pPr algn="ctr"/>
-            <a:r>
-              <a:rPr sz="1400" b="1">
-                <a:solidFill>
-                  <a:srgbClr val="22C55E"/>
-                </a:solidFill>
-                <a:latin typeface="Calibri"/>
-              </a:rPr>
-              <a:t>✓</a:t>
-            </a:r>
-          </a:p>
-        </p:txBody>
-      </p:sp>
-      <p:sp>
-        <p:nvSpPr>
-          <p:cNvPr id="34" name="Rectangle 33"/>
-          <p:cNvSpPr/>
-          <p:nvPr/>
-        </p:nvSpPr>
-        <p:spPr>
-          <a:xfrm>
             <a:off x="365760" y="3264408"/>
-            <a:ext cx="2926080" cy="420624"/>
+            <a:ext cx="3840480" cy="420624"/>
           </a:xfrm>
           <a:prstGeom prst="rect">
             <a:avLst/>
@@ -4843,14 +4683,14 @@
       </p:sp>
       <p:sp>
         <p:nvSpPr>
-          <p:cNvPr id="35" name="TextBox 34"/>
+          <p:cNvPr id="31" name="TextBox 30"/>
           <p:cNvSpPr txBox="1"/>
           <p:nvPr/>
         </p:nvSpPr>
         <p:spPr>
           <a:xfrm>
             <a:off x="457200" y="3355848"/>
-            <a:ext cx="2788920" cy="256032"/>
+            <a:ext cx="3703320" cy="256032"/>
           </a:xfrm>
           <a:prstGeom prst="rect">
             <a:avLst/>
@@ -4871,21 +4711,21 @@
                 </a:solidFill>
                 <a:latin typeface="Calibri"/>
               </a:rPr>
-              <a:t>Academic Writing</a:t>
-            </a:r>
-          </a:p>
-        </p:txBody>
-      </p:sp>
-      <p:sp>
-        <p:nvSpPr>
-          <p:cNvPr id="36" name="Rectangle 35"/>
+              <a:t>Write academic research papers</a:t>
+            </a:r>
+          </a:p>
+        </p:txBody>
+      </p:sp>
+      <p:sp>
+        <p:nvSpPr>
+          <p:cNvPr id="32" name="Rectangle 31"/>
           <p:cNvSpPr/>
           <p:nvPr/>
         </p:nvSpPr>
         <p:spPr>
           <a:xfrm>
-            <a:off x="3291840" y="3264408"/>
-            <a:ext cx="1463040" cy="420624"/>
+            <a:off x="4206240" y="3264408"/>
+            <a:ext cx="1645920" cy="420624"/>
           </a:xfrm>
           <a:prstGeom prst="rect">
             <a:avLst/>
@@ -4923,14 +4763,14 @@
       </p:sp>
       <p:sp>
         <p:nvSpPr>
-          <p:cNvPr id="37" name="TextBox 36"/>
-          <p:cNvSpPr txBox="1"/>
-          <p:nvPr/>
-        </p:nvSpPr>
-        <p:spPr>
-          <a:xfrm>
-            <a:off x="3291840" y="3328416"/>
-            <a:ext cx="1463040" cy="292608"/>
+          <p:cNvPr id="33" name="TextBox 32"/>
+          <p:cNvSpPr txBox="1"/>
+          <p:nvPr/>
+        </p:nvSpPr>
+        <p:spPr>
+          <a:xfrm>
+            <a:off x="4206240" y="3328416"/>
+            <a:ext cx="1645920" cy="292608"/>
           </a:xfrm>
           <a:prstGeom prst="rect">
             <a:avLst/>
@@ -4958,14 +4798,14 @@
       </p:sp>
       <p:sp>
         <p:nvSpPr>
-          <p:cNvPr id="38" name="Rectangle 37"/>
+          <p:cNvPr id="34" name="Rectangle 33"/>
           <p:cNvSpPr/>
           <p:nvPr/>
         </p:nvSpPr>
         <p:spPr>
           <a:xfrm>
-            <a:off x="4754880" y="3264408"/>
-            <a:ext cx="1463040" cy="420624"/>
+            <a:off x="5852160" y="3264408"/>
+            <a:ext cx="1645920" cy="420624"/>
           </a:xfrm>
           <a:prstGeom prst="rect">
             <a:avLst/>
@@ -5003,14 +4843,14 @@
       </p:sp>
       <p:sp>
         <p:nvSpPr>
-          <p:cNvPr id="39" name="TextBox 38"/>
-          <p:cNvSpPr txBox="1"/>
-          <p:nvPr/>
-        </p:nvSpPr>
-        <p:spPr>
-          <a:xfrm>
-            <a:off x="4754880" y="3328416"/>
-            <a:ext cx="1463040" cy="292608"/>
+          <p:cNvPr id="35" name="TextBox 34"/>
+          <p:cNvSpPr txBox="1"/>
+          <p:nvPr/>
+        </p:nvSpPr>
+        <p:spPr>
+          <a:xfrm>
+            <a:off x="5852160" y="3328416"/>
+            <a:ext cx="1645920" cy="292608"/>
           </a:xfrm>
           <a:prstGeom prst="rect">
             <a:avLst/>
@@ -5038,14 +4878,14 @@
       </p:sp>
       <p:sp>
         <p:nvSpPr>
-          <p:cNvPr id="40" name="Rectangle 39"/>
+          <p:cNvPr id="36" name="Rectangle 35"/>
           <p:cNvSpPr/>
           <p:nvPr/>
         </p:nvSpPr>
         <p:spPr>
           <a:xfrm>
-            <a:off x="6217920" y="3264408"/>
-            <a:ext cx="1463040" cy="420624"/>
+            <a:off x="7498080" y="3264408"/>
+            <a:ext cx="1645920" cy="420624"/>
           </a:xfrm>
           <a:prstGeom prst="rect">
             <a:avLst/>
@@ -5083,14 +4923,14 @@
       </p:sp>
       <p:sp>
         <p:nvSpPr>
-          <p:cNvPr id="41" name="TextBox 40"/>
-          <p:cNvSpPr txBox="1"/>
-          <p:nvPr/>
-        </p:nvSpPr>
-        <p:spPr>
-          <a:xfrm>
-            <a:off x="6217920" y="3328416"/>
-            <a:ext cx="1463040" cy="292608"/>
+          <p:cNvPr id="37" name="TextBox 36"/>
+          <p:cNvSpPr txBox="1"/>
+          <p:nvPr/>
+        </p:nvSpPr>
+        <p:spPr>
+          <a:xfrm>
+            <a:off x="7498080" y="3328416"/>
+            <a:ext cx="1645920" cy="292608"/>
           </a:xfrm>
           <a:prstGeom prst="rect">
             <a:avLst/>
@@ -5107,25 +4947,25 @@
             <a:r>
               <a:rPr sz="1400" b="1">
                 <a:solidFill>
-                  <a:srgbClr val="EF4444"/>
-                </a:solidFill>
-                <a:latin typeface="Calibri"/>
-              </a:rPr>
-              <a:t>✗</a:t>
-            </a:r>
-          </a:p>
-        </p:txBody>
-      </p:sp>
-      <p:sp>
-        <p:nvSpPr>
-          <p:cNvPr id="42" name="Rectangle 41"/>
+                  <a:srgbClr val="22C55E"/>
+                </a:solidFill>
+                <a:latin typeface="Calibri"/>
+              </a:rPr>
+              <a:t>✓</a:t>
+            </a:r>
+          </a:p>
+        </p:txBody>
+      </p:sp>
+      <p:sp>
+        <p:nvSpPr>
+          <p:cNvPr id="38" name="Rectangle 37"/>
           <p:cNvSpPr/>
           <p:nvPr/>
         </p:nvSpPr>
         <p:spPr>
           <a:xfrm>
-            <a:off x="7680960" y="3264408"/>
-            <a:ext cx="1463040" cy="420624"/>
+            <a:off x="9144000" y="3264408"/>
+            <a:ext cx="1783080" cy="420624"/>
           </a:xfrm>
           <a:prstGeom prst="rect">
             <a:avLst/>
@@ -5163,14 +5003,14 @@
       </p:sp>
       <p:sp>
         <p:nvSpPr>
-          <p:cNvPr id="43" name="TextBox 42"/>
-          <p:cNvSpPr txBox="1"/>
-          <p:nvPr/>
-        </p:nvSpPr>
-        <p:spPr>
-          <a:xfrm>
-            <a:off x="7680960" y="3328416"/>
-            <a:ext cx="1463040" cy="292608"/>
+          <p:cNvPr id="39" name="TextBox 38"/>
+          <p:cNvSpPr txBox="1"/>
+          <p:nvPr/>
+        </p:nvSpPr>
+        <p:spPr>
+          <a:xfrm>
+            <a:off x="9144000" y="3328416"/>
+            <a:ext cx="1783080" cy="292608"/>
           </a:xfrm>
           <a:prstGeom prst="rect">
             <a:avLst/>
@@ -5198,94 +5038,14 @@
       </p:sp>
       <p:sp>
         <p:nvSpPr>
-          <p:cNvPr id="44" name="Rectangle 43"/>
+          <p:cNvPr id="40" name="Rectangle 39"/>
           <p:cNvSpPr/>
           <p:nvPr/>
         </p:nvSpPr>
         <p:spPr>
           <a:xfrm>
-            <a:off x="9144000" y="3264408"/>
-            <a:ext cx="1737360" cy="420624"/>
-          </a:xfrm>
-          <a:prstGeom prst="rect">
-            <a:avLst/>
-          </a:prstGeom>
-          <a:solidFill>
-            <a:srgbClr val="201900"/>
-          </a:solidFill>
-          <a:ln w="12700">
-            <a:solidFill>
-              <a:srgbClr val="252A40"/>
-            </a:solidFill>
-          </a:ln>
-        </p:spPr>
-        <p:style>
-          <a:lnRef idx="1">
-            <a:schemeClr val="accent1"/>
-          </a:lnRef>
-          <a:fillRef idx="3">
-            <a:schemeClr val="accent1"/>
-          </a:fillRef>
-          <a:effectRef idx="2">
-            <a:schemeClr val="accent1"/>
-          </a:effectRef>
-          <a:fontRef idx="minor">
-            <a:schemeClr val="lt1"/>
-          </a:fontRef>
-        </p:style>
-        <p:txBody>
-          <a:bodyPr rtlCol="0" anchor="ctr"/>
-          <a:lstStyle/>
-          <a:p>
-            <a:pPr algn="ctr"/>
-          </a:p>
-        </p:txBody>
-      </p:sp>
-      <p:sp>
-        <p:nvSpPr>
-          <p:cNvPr id="45" name="TextBox 44"/>
-          <p:cNvSpPr txBox="1"/>
-          <p:nvPr/>
-        </p:nvSpPr>
-        <p:spPr>
-          <a:xfrm>
-            <a:off x="9144000" y="3328416"/>
-            <a:ext cx="1737360" cy="292608"/>
-          </a:xfrm>
-          <a:prstGeom prst="rect">
-            <a:avLst/>
-          </a:prstGeom>
-          <a:noFill/>
-        </p:spPr>
-        <p:txBody>
-          <a:bodyPr wrap="square" lIns="45720" rIns="45720" tIns="18288" bIns="18288">
-            <a:spAutoFit/>
-          </a:bodyPr>
-          <a:lstStyle/>
-          <a:p>
-            <a:pPr algn="ctr"/>
-            <a:r>
-              <a:rPr sz="1400" b="1">
-                <a:solidFill>
-                  <a:srgbClr val="22C55E"/>
-                </a:solidFill>
-                <a:latin typeface="Calibri"/>
-              </a:rPr>
-              <a:t>✓</a:t>
-            </a:r>
-          </a:p>
-        </p:txBody>
-      </p:sp>
-      <p:sp>
-        <p:nvSpPr>
-          <p:cNvPr id="46" name="Rectangle 45"/>
-          <p:cNvSpPr/>
-          <p:nvPr/>
-        </p:nvSpPr>
-        <p:spPr>
-          <a:xfrm>
             <a:off x="365760" y="3685032"/>
-            <a:ext cx="2926080" cy="420624"/>
+            <a:ext cx="3840480" cy="420624"/>
           </a:xfrm>
           <a:prstGeom prst="rect">
             <a:avLst/>
@@ -5323,14 +5083,14 @@
       </p:sp>
       <p:sp>
         <p:nvSpPr>
-          <p:cNvPr id="47" name="TextBox 46"/>
+          <p:cNvPr id="41" name="TextBox 40"/>
           <p:cNvSpPr txBox="1"/>
           <p:nvPr/>
         </p:nvSpPr>
         <p:spPr>
           <a:xfrm>
             <a:off x="457200" y="3776472"/>
-            <a:ext cx="2788920" cy="256032"/>
+            <a:ext cx="3703320" cy="256032"/>
           </a:xfrm>
           <a:prstGeom prst="rect">
             <a:avLst/>
@@ -5351,21 +5111,21 @@
                 </a:solidFill>
                 <a:latin typeface="Calibri"/>
               </a:rPr>
-              <a:t>Citation Formatting</a:t>
-            </a:r>
-          </a:p>
-        </p:txBody>
-      </p:sp>
-      <p:sp>
-        <p:nvSpPr>
-          <p:cNvPr id="48" name="Rectangle 47"/>
+              <a:t>Manage research knowledge &amp; memory</a:t>
+            </a:r>
+          </a:p>
+        </p:txBody>
+      </p:sp>
+      <p:sp>
+        <p:nvSpPr>
+          <p:cNvPr id="42" name="Rectangle 41"/>
           <p:cNvSpPr/>
           <p:nvPr/>
         </p:nvSpPr>
         <p:spPr>
           <a:xfrm>
-            <a:off x="3291840" y="3685032"/>
-            <a:ext cx="1463040" cy="420624"/>
+            <a:off x="4206240" y="3685032"/>
+            <a:ext cx="1645920" cy="420624"/>
           </a:xfrm>
           <a:prstGeom prst="rect">
             <a:avLst/>
@@ -5403,14 +5163,14 @@
       </p:sp>
       <p:sp>
         <p:nvSpPr>
-          <p:cNvPr id="49" name="TextBox 48"/>
-          <p:cNvSpPr txBox="1"/>
-          <p:nvPr/>
-        </p:nvSpPr>
-        <p:spPr>
-          <a:xfrm>
-            <a:off x="3291840" y="3749040"/>
-            <a:ext cx="1463040" cy="292608"/>
+          <p:cNvPr id="43" name="TextBox 42"/>
+          <p:cNvSpPr txBox="1"/>
+          <p:nvPr/>
+        </p:nvSpPr>
+        <p:spPr>
+          <a:xfrm>
+            <a:off x="4206240" y="3749040"/>
+            <a:ext cx="1645920" cy="292608"/>
           </a:xfrm>
           <a:prstGeom prst="rect">
             <a:avLst/>
@@ -5427,25 +5187,25 @@
             <a:r>
               <a:rPr sz="1400" b="1">
                 <a:solidFill>
-                  <a:srgbClr val="FFC107"/>
-                </a:solidFill>
-                <a:latin typeface="Calibri"/>
-              </a:rPr>
-              <a:t>~</a:t>
-            </a:r>
-          </a:p>
-        </p:txBody>
-      </p:sp>
-      <p:sp>
-        <p:nvSpPr>
-          <p:cNvPr id="50" name="Rectangle 49"/>
+                  <a:srgbClr val="EF4444"/>
+                </a:solidFill>
+                <a:latin typeface="Calibri"/>
+              </a:rPr>
+              <a:t>✗</a:t>
+            </a:r>
+          </a:p>
+        </p:txBody>
+      </p:sp>
+      <p:sp>
+        <p:nvSpPr>
+          <p:cNvPr id="44" name="Rectangle 43"/>
           <p:cNvSpPr/>
           <p:nvPr/>
         </p:nvSpPr>
         <p:spPr>
           <a:xfrm>
-            <a:off x="4754880" y="3685032"/>
-            <a:ext cx="1463040" cy="420624"/>
+            <a:off x="5852160" y="3685032"/>
+            <a:ext cx="1645920" cy="420624"/>
           </a:xfrm>
           <a:prstGeom prst="rect">
             <a:avLst/>
@@ -5483,14 +5243,14 @@
       </p:sp>
       <p:sp>
         <p:nvSpPr>
-          <p:cNvPr id="51" name="TextBox 50"/>
-          <p:cNvSpPr txBox="1"/>
-          <p:nvPr/>
-        </p:nvSpPr>
-        <p:spPr>
-          <a:xfrm>
-            <a:off x="4754880" y="3749040"/>
-            <a:ext cx="1463040" cy="292608"/>
+          <p:cNvPr id="45" name="TextBox 44"/>
+          <p:cNvSpPr txBox="1"/>
+          <p:nvPr/>
+        </p:nvSpPr>
+        <p:spPr>
+          <a:xfrm>
+            <a:off x="5852160" y="3749040"/>
+            <a:ext cx="1645920" cy="292608"/>
           </a:xfrm>
           <a:prstGeom prst="rect">
             <a:avLst/>
@@ -5507,25 +5267,25 @@
             <a:r>
               <a:rPr sz="1400" b="1">
                 <a:solidFill>
-                  <a:srgbClr val="22C55E"/>
-                </a:solidFill>
-                <a:latin typeface="Calibri"/>
-              </a:rPr>
-              <a:t>✓</a:t>
-            </a:r>
-          </a:p>
-        </p:txBody>
-      </p:sp>
-      <p:sp>
-        <p:nvSpPr>
-          <p:cNvPr id="52" name="Rectangle 51"/>
+                  <a:srgbClr val="EF4444"/>
+                </a:solidFill>
+                <a:latin typeface="Calibri"/>
+              </a:rPr>
+              <a:t>✗</a:t>
+            </a:r>
+          </a:p>
+        </p:txBody>
+      </p:sp>
+      <p:sp>
+        <p:nvSpPr>
+          <p:cNvPr id="46" name="Rectangle 45"/>
           <p:cNvSpPr/>
           <p:nvPr/>
         </p:nvSpPr>
         <p:spPr>
           <a:xfrm>
-            <a:off x="6217920" y="3685032"/>
-            <a:ext cx="1463040" cy="420624"/>
+            <a:off x="7498080" y="3685032"/>
+            <a:ext cx="1645920" cy="420624"/>
           </a:xfrm>
           <a:prstGeom prst="rect">
             <a:avLst/>
@@ -5563,14 +5323,14 @@
       </p:sp>
       <p:sp>
         <p:nvSpPr>
-          <p:cNvPr id="53" name="TextBox 52"/>
-          <p:cNvSpPr txBox="1"/>
-          <p:nvPr/>
-        </p:nvSpPr>
-        <p:spPr>
-          <a:xfrm>
-            <a:off x="6217920" y="3749040"/>
-            <a:ext cx="1463040" cy="292608"/>
+          <p:cNvPr id="47" name="TextBox 46"/>
+          <p:cNvSpPr txBox="1"/>
+          <p:nvPr/>
+        </p:nvSpPr>
+        <p:spPr>
+          <a:xfrm>
+            <a:off x="7498080" y="3749040"/>
+            <a:ext cx="1645920" cy="292608"/>
           </a:xfrm>
           <a:prstGeom prst="rect">
             <a:avLst/>
@@ -5587,25 +5347,25 @@
             <a:r>
               <a:rPr sz="1400" b="1">
                 <a:solidFill>
-                  <a:srgbClr val="22C55E"/>
-                </a:solidFill>
-                <a:latin typeface="Calibri"/>
-              </a:rPr>
-              <a:t>✓</a:t>
-            </a:r>
-          </a:p>
-        </p:txBody>
-      </p:sp>
-      <p:sp>
-        <p:nvSpPr>
-          <p:cNvPr id="54" name="Rectangle 53"/>
+                  <a:srgbClr val="EF4444"/>
+                </a:solidFill>
+                <a:latin typeface="Calibri"/>
+              </a:rPr>
+              <a:t>✗</a:t>
+            </a:r>
+          </a:p>
+        </p:txBody>
+      </p:sp>
+      <p:sp>
+        <p:nvSpPr>
+          <p:cNvPr id="48" name="Rectangle 47"/>
           <p:cNvSpPr/>
           <p:nvPr/>
         </p:nvSpPr>
         <p:spPr>
           <a:xfrm>
-            <a:off x="7680960" y="3685032"/>
-            <a:ext cx="1463040" cy="420624"/>
+            <a:off x="9144000" y="3685032"/>
+            <a:ext cx="1783080" cy="420624"/>
           </a:xfrm>
           <a:prstGeom prst="rect">
             <a:avLst/>
@@ -5643,14 +5403,14 @@
       </p:sp>
       <p:sp>
         <p:nvSpPr>
-          <p:cNvPr id="55" name="TextBox 54"/>
-          <p:cNvSpPr txBox="1"/>
-          <p:nvPr/>
-        </p:nvSpPr>
-        <p:spPr>
-          <a:xfrm>
-            <a:off x="7680960" y="3749040"/>
-            <a:ext cx="1463040" cy="292608"/>
+          <p:cNvPr id="49" name="TextBox 48"/>
+          <p:cNvSpPr txBox="1"/>
+          <p:nvPr/>
+        </p:nvSpPr>
+        <p:spPr>
+          <a:xfrm>
+            <a:off x="9144000" y="3749040"/>
+            <a:ext cx="1783080" cy="292608"/>
           </a:xfrm>
           <a:prstGeom prst="rect">
             <a:avLst/>
@@ -5678,94 +5438,14 @@
       </p:sp>
       <p:sp>
         <p:nvSpPr>
-          <p:cNvPr id="56" name="Rectangle 55"/>
+          <p:cNvPr id="50" name="Rectangle 49"/>
           <p:cNvSpPr/>
           <p:nvPr/>
         </p:nvSpPr>
         <p:spPr>
           <a:xfrm>
-            <a:off x="9144000" y="3685032"/>
-            <a:ext cx="1737360" cy="420624"/>
-          </a:xfrm>
-          <a:prstGeom prst="rect">
-            <a:avLst/>
-          </a:prstGeom>
-          <a:solidFill>
-            <a:srgbClr val="201900"/>
-          </a:solidFill>
-          <a:ln w="12700">
-            <a:solidFill>
-              <a:srgbClr val="252A40"/>
-            </a:solidFill>
-          </a:ln>
-        </p:spPr>
-        <p:style>
-          <a:lnRef idx="1">
-            <a:schemeClr val="accent1"/>
-          </a:lnRef>
-          <a:fillRef idx="3">
-            <a:schemeClr val="accent1"/>
-          </a:fillRef>
-          <a:effectRef idx="2">
-            <a:schemeClr val="accent1"/>
-          </a:effectRef>
-          <a:fontRef idx="minor">
-            <a:schemeClr val="lt1"/>
-          </a:fontRef>
-        </p:style>
-        <p:txBody>
-          <a:bodyPr rtlCol="0" anchor="ctr"/>
-          <a:lstStyle/>
-          <a:p>
-            <a:pPr algn="ctr"/>
-          </a:p>
-        </p:txBody>
-      </p:sp>
-      <p:sp>
-        <p:nvSpPr>
-          <p:cNvPr id="57" name="TextBox 56"/>
-          <p:cNvSpPr txBox="1"/>
-          <p:nvPr/>
-        </p:nvSpPr>
-        <p:spPr>
-          <a:xfrm>
-            <a:off x="9144000" y="3749040"/>
-            <a:ext cx="1737360" cy="292608"/>
-          </a:xfrm>
-          <a:prstGeom prst="rect">
-            <a:avLst/>
-          </a:prstGeom>
-          <a:noFill/>
-        </p:spPr>
-        <p:txBody>
-          <a:bodyPr wrap="square" lIns="45720" rIns="45720" tIns="18288" bIns="18288">
-            <a:spAutoFit/>
-          </a:bodyPr>
-          <a:lstStyle/>
-          <a:p>
-            <a:pPr algn="ctr"/>
-            <a:r>
-              <a:rPr sz="1400" b="1">
-                <a:solidFill>
-                  <a:srgbClr val="22C55E"/>
-                </a:solidFill>
-                <a:latin typeface="Calibri"/>
-              </a:rPr>
-              <a:t>✓</a:t>
-            </a:r>
-          </a:p>
-        </p:txBody>
-      </p:sp>
-      <p:sp>
-        <p:nvSpPr>
-          <p:cNvPr id="58" name="Rectangle 57"/>
-          <p:cNvSpPr/>
-          <p:nvPr/>
-        </p:nvSpPr>
-        <p:spPr>
-          <a:xfrm>
             <a:off x="365760" y="4105656"/>
-            <a:ext cx="2926080" cy="420624"/>
+            <a:ext cx="3840480" cy="420624"/>
           </a:xfrm>
           <a:prstGeom prst="rect">
             <a:avLst/>
@@ -5803,14 +5483,14 @@
       </p:sp>
       <p:sp>
         <p:nvSpPr>
-          <p:cNvPr id="59" name="TextBox 58"/>
+          <p:cNvPr id="51" name="TextBox 50"/>
           <p:cNvSpPr txBox="1"/>
           <p:nvPr/>
         </p:nvSpPr>
         <p:spPr>
           <a:xfrm>
             <a:off x="457200" y="4197096"/>
-            <a:ext cx="2788920" cy="256032"/>
+            <a:ext cx="3703320" cy="256032"/>
           </a:xfrm>
           <a:prstGeom prst="rect">
             <a:avLst/>
@@ -5831,21 +5511,21 @@
                 </a:solidFill>
                 <a:latin typeface="Calibri"/>
               </a:rPr>
-              <a:t>Document Library</a:t>
-            </a:r>
-          </a:p>
-        </p:txBody>
-      </p:sp>
-      <p:sp>
-        <p:nvSpPr>
-          <p:cNvPr id="60" name="Rectangle 59"/>
+              <a:t>Generate formatted citations</a:t>
+            </a:r>
+          </a:p>
+        </p:txBody>
+      </p:sp>
+      <p:sp>
+        <p:nvSpPr>
+          <p:cNvPr id="52" name="Rectangle 51"/>
           <p:cNvSpPr/>
           <p:nvPr/>
         </p:nvSpPr>
         <p:spPr>
           <a:xfrm>
-            <a:off x="3291840" y="4105656"/>
-            <a:ext cx="1463040" cy="420624"/>
+            <a:off x="4206240" y="4105656"/>
+            <a:ext cx="1645920" cy="420624"/>
           </a:xfrm>
           <a:prstGeom prst="rect">
             <a:avLst/>
@@ -5883,14 +5563,14 @@
       </p:sp>
       <p:sp>
         <p:nvSpPr>
-          <p:cNvPr id="61" name="TextBox 60"/>
-          <p:cNvSpPr txBox="1"/>
-          <p:nvPr/>
-        </p:nvSpPr>
-        <p:spPr>
-          <a:xfrm>
-            <a:off x="3291840" y="4169664"/>
-            <a:ext cx="1463040" cy="292608"/>
+          <p:cNvPr id="53" name="TextBox 52"/>
+          <p:cNvSpPr txBox="1"/>
+          <p:nvPr/>
+        </p:nvSpPr>
+        <p:spPr>
+          <a:xfrm>
+            <a:off x="4206240" y="4169664"/>
+            <a:ext cx="1645920" cy="292608"/>
           </a:xfrm>
           <a:prstGeom prst="rect">
             <a:avLst/>
@@ -5907,25 +5587,25 @@
             <a:r>
               <a:rPr sz="1400" b="1">
                 <a:solidFill>
-                  <a:srgbClr val="EF4444"/>
-                </a:solidFill>
-                <a:latin typeface="Calibri"/>
-              </a:rPr>
-              <a:t>✗</a:t>
-            </a:r>
-          </a:p>
-        </p:txBody>
-      </p:sp>
-      <p:sp>
-        <p:nvSpPr>
-          <p:cNvPr id="62" name="Rectangle 61"/>
+                  <a:srgbClr val="FFC107"/>
+                </a:solidFill>
+                <a:latin typeface="Calibri"/>
+              </a:rPr>
+              <a:t>~</a:t>
+            </a:r>
+          </a:p>
+        </p:txBody>
+      </p:sp>
+      <p:sp>
+        <p:nvSpPr>
+          <p:cNvPr id="54" name="Rectangle 53"/>
           <p:cNvSpPr/>
           <p:nvPr/>
         </p:nvSpPr>
         <p:spPr>
           <a:xfrm>
-            <a:off x="4754880" y="4105656"/>
-            <a:ext cx="1463040" cy="420624"/>
+            <a:off x="5852160" y="4105656"/>
+            <a:ext cx="1645920" cy="420624"/>
           </a:xfrm>
           <a:prstGeom prst="rect">
             <a:avLst/>
@@ -5963,14 +5643,14 @@
       </p:sp>
       <p:sp>
         <p:nvSpPr>
-          <p:cNvPr id="63" name="TextBox 62"/>
-          <p:cNvSpPr txBox="1"/>
-          <p:nvPr/>
-        </p:nvSpPr>
-        <p:spPr>
-          <a:xfrm>
-            <a:off x="4754880" y="4169664"/>
-            <a:ext cx="1463040" cy="292608"/>
+          <p:cNvPr id="55" name="TextBox 54"/>
+          <p:cNvSpPr txBox="1"/>
+          <p:nvPr/>
+        </p:nvSpPr>
+        <p:spPr>
+          <a:xfrm>
+            <a:off x="5852160" y="4169664"/>
+            <a:ext cx="1645920" cy="292608"/>
           </a:xfrm>
           <a:prstGeom prst="rect">
             <a:avLst/>
@@ -5987,25 +5667,25 @@
             <a:r>
               <a:rPr sz="1400" b="1">
                 <a:solidFill>
-                  <a:srgbClr val="EF4444"/>
-                </a:solidFill>
-                <a:latin typeface="Calibri"/>
-              </a:rPr>
-              <a:t>✗</a:t>
-            </a:r>
-          </a:p>
-        </p:txBody>
-      </p:sp>
-      <p:sp>
-        <p:nvSpPr>
-          <p:cNvPr id="64" name="Rectangle 63"/>
+                  <a:srgbClr val="22C55E"/>
+                </a:solidFill>
+                <a:latin typeface="Calibri"/>
+              </a:rPr>
+              <a:t>✓</a:t>
+            </a:r>
+          </a:p>
+        </p:txBody>
+      </p:sp>
+      <p:sp>
+        <p:nvSpPr>
+          <p:cNvPr id="56" name="Rectangle 55"/>
           <p:cNvSpPr/>
           <p:nvPr/>
         </p:nvSpPr>
         <p:spPr>
           <a:xfrm>
-            <a:off x="6217920" y="4105656"/>
-            <a:ext cx="1463040" cy="420624"/>
+            <a:off x="7498080" y="4105656"/>
+            <a:ext cx="1645920" cy="420624"/>
           </a:xfrm>
           <a:prstGeom prst="rect">
             <a:avLst/>
@@ -6043,14 +5723,14 @@
       </p:sp>
       <p:sp>
         <p:nvSpPr>
-          <p:cNvPr id="65" name="TextBox 64"/>
-          <p:cNvSpPr txBox="1"/>
-          <p:nvPr/>
-        </p:nvSpPr>
-        <p:spPr>
-          <a:xfrm>
-            <a:off x="6217920" y="4169664"/>
-            <a:ext cx="1463040" cy="292608"/>
+          <p:cNvPr id="57" name="TextBox 56"/>
+          <p:cNvSpPr txBox="1"/>
+          <p:nvPr/>
+        </p:nvSpPr>
+        <p:spPr>
+          <a:xfrm>
+            <a:off x="7498080" y="4169664"/>
+            <a:ext cx="1645920" cy="292608"/>
           </a:xfrm>
           <a:prstGeom prst="rect">
             <a:avLst/>
@@ -6067,25 +5747,25 @@
             <a:r>
               <a:rPr sz="1400" b="1">
                 <a:solidFill>
-                  <a:srgbClr val="EF4444"/>
-                </a:solidFill>
-                <a:latin typeface="Calibri"/>
-              </a:rPr>
-              <a:t>✗</a:t>
-            </a:r>
-          </a:p>
-        </p:txBody>
-      </p:sp>
-      <p:sp>
-        <p:nvSpPr>
-          <p:cNvPr id="66" name="Rectangle 65"/>
+                  <a:srgbClr val="22C55E"/>
+                </a:solidFill>
+                <a:latin typeface="Calibri"/>
+              </a:rPr>
+              <a:t>✓</a:t>
+            </a:r>
+          </a:p>
+        </p:txBody>
+      </p:sp>
+      <p:sp>
+        <p:nvSpPr>
+          <p:cNvPr id="58" name="Rectangle 57"/>
           <p:cNvSpPr/>
           <p:nvPr/>
         </p:nvSpPr>
         <p:spPr>
           <a:xfrm>
-            <a:off x="7680960" y="4105656"/>
-            <a:ext cx="1463040" cy="420624"/>
+            <a:off x="9144000" y="4105656"/>
+            <a:ext cx="1783080" cy="420624"/>
           </a:xfrm>
           <a:prstGeom prst="rect">
             <a:avLst/>
@@ -6123,14 +5803,14 @@
       </p:sp>
       <p:sp>
         <p:nvSpPr>
-          <p:cNvPr id="67" name="TextBox 66"/>
-          <p:cNvSpPr txBox="1"/>
-          <p:nvPr/>
-        </p:nvSpPr>
-        <p:spPr>
-          <a:xfrm>
-            <a:off x="7680960" y="4169664"/>
-            <a:ext cx="1463040" cy="292608"/>
+          <p:cNvPr id="59" name="TextBox 58"/>
+          <p:cNvSpPr txBox="1"/>
+          <p:nvPr/>
+        </p:nvSpPr>
+        <p:spPr>
+          <a:xfrm>
+            <a:off x="9144000" y="4169664"/>
+            <a:ext cx="1783080" cy="292608"/>
           </a:xfrm>
           <a:prstGeom prst="rect">
             <a:avLst/>
@@ -6147,105 +5827,25 @@
             <a:r>
               <a:rPr sz="1400" b="1">
                 <a:solidFill>
-                  <a:srgbClr val="EF4444"/>
-                </a:solidFill>
-                <a:latin typeface="Calibri"/>
-              </a:rPr>
-              <a:t>✗</a:t>
-            </a:r>
-          </a:p>
-        </p:txBody>
-      </p:sp>
-      <p:sp>
-        <p:nvSpPr>
-          <p:cNvPr id="68" name="Rectangle 67"/>
+                  <a:srgbClr val="22C55E"/>
+                </a:solidFill>
+                <a:latin typeface="Calibri"/>
+              </a:rPr>
+              <a:t>✓</a:t>
+            </a:r>
+          </a:p>
+        </p:txBody>
+      </p:sp>
+      <p:sp>
+        <p:nvSpPr>
+          <p:cNvPr id="60" name="Rectangle 59"/>
           <p:cNvSpPr/>
           <p:nvPr/>
         </p:nvSpPr>
         <p:spPr>
           <a:xfrm>
-            <a:off x="9144000" y="4105656"/>
-            <a:ext cx="1737360" cy="420624"/>
-          </a:xfrm>
-          <a:prstGeom prst="rect">
-            <a:avLst/>
-          </a:prstGeom>
-          <a:solidFill>
-            <a:srgbClr val="201900"/>
-          </a:solidFill>
-          <a:ln w="12700">
-            <a:solidFill>
-              <a:srgbClr val="252A40"/>
-            </a:solidFill>
-          </a:ln>
-        </p:spPr>
-        <p:style>
-          <a:lnRef idx="1">
-            <a:schemeClr val="accent1"/>
-          </a:lnRef>
-          <a:fillRef idx="3">
-            <a:schemeClr val="accent1"/>
-          </a:fillRef>
-          <a:effectRef idx="2">
-            <a:schemeClr val="accent1"/>
-          </a:effectRef>
-          <a:fontRef idx="minor">
-            <a:schemeClr val="lt1"/>
-          </a:fontRef>
-        </p:style>
-        <p:txBody>
-          <a:bodyPr rtlCol="0" anchor="ctr"/>
-          <a:lstStyle/>
-          <a:p>
-            <a:pPr algn="ctr"/>
-          </a:p>
-        </p:txBody>
-      </p:sp>
-      <p:sp>
-        <p:nvSpPr>
-          <p:cNvPr id="69" name="TextBox 68"/>
-          <p:cNvSpPr txBox="1"/>
-          <p:nvPr/>
-        </p:nvSpPr>
-        <p:spPr>
-          <a:xfrm>
-            <a:off x="9144000" y="4169664"/>
-            <a:ext cx="1737360" cy="292608"/>
-          </a:xfrm>
-          <a:prstGeom prst="rect">
-            <a:avLst/>
-          </a:prstGeom>
-          <a:noFill/>
-        </p:spPr>
-        <p:txBody>
-          <a:bodyPr wrap="square" lIns="45720" rIns="45720" tIns="18288" bIns="18288">
-            <a:spAutoFit/>
-          </a:bodyPr>
-          <a:lstStyle/>
-          <a:p>
-            <a:pPr algn="ctr"/>
-            <a:r>
-              <a:rPr sz="1400" b="1">
-                <a:solidFill>
-                  <a:srgbClr val="22C55E"/>
-                </a:solidFill>
-                <a:latin typeface="Calibri"/>
-              </a:rPr>
-              <a:t>✓</a:t>
-            </a:r>
-          </a:p>
-        </p:txBody>
-      </p:sp>
-      <p:sp>
-        <p:nvSpPr>
-          <p:cNvPr id="70" name="Rectangle 69"/>
-          <p:cNvSpPr/>
-          <p:nvPr/>
-        </p:nvSpPr>
-        <p:spPr>
-          <a:xfrm>
             <a:off x="365760" y="4526280"/>
-            <a:ext cx="2926080" cy="420624"/>
+            <a:ext cx="3840480" cy="420624"/>
           </a:xfrm>
           <a:prstGeom prst="rect">
             <a:avLst/>
@@ -6283,14 +5883,14 @@
       </p:sp>
       <p:sp>
         <p:nvSpPr>
-          <p:cNvPr id="71" name="TextBox 70"/>
+          <p:cNvPr id="61" name="TextBox 60"/>
           <p:cNvSpPr txBox="1"/>
           <p:nvPr/>
         </p:nvSpPr>
         <p:spPr>
           <a:xfrm>
             <a:off x="457200" y="4617720"/>
-            <a:ext cx="2788920" cy="256032"/>
+            <a:ext cx="3703320" cy="256032"/>
           </a:xfrm>
           <a:prstGeom prst="rect">
             <a:avLst/>
@@ -6311,21 +5911,21 @@
                 </a:solidFill>
                 <a:latin typeface="Calibri"/>
               </a:rPr>
-              <a:t>Presentation Creation</a:t>
-            </a:r>
-          </a:p>
-        </p:txBody>
-      </p:sp>
-      <p:sp>
-        <p:nvSpPr>
-          <p:cNvPr id="72" name="Rectangle 71"/>
+              <a:t>Create presentations &amp; visuals</a:t>
+            </a:r>
+          </a:p>
+        </p:txBody>
+      </p:sp>
+      <p:sp>
+        <p:nvSpPr>
+          <p:cNvPr id="62" name="Rectangle 61"/>
           <p:cNvSpPr/>
           <p:nvPr/>
         </p:nvSpPr>
         <p:spPr>
           <a:xfrm>
-            <a:off x="3291840" y="4526280"/>
-            <a:ext cx="1463040" cy="420624"/>
+            <a:off x="4206240" y="4526280"/>
+            <a:ext cx="1645920" cy="420624"/>
           </a:xfrm>
           <a:prstGeom prst="rect">
             <a:avLst/>
@@ -6363,14 +5963,14 @@
       </p:sp>
       <p:sp>
         <p:nvSpPr>
-          <p:cNvPr id="73" name="TextBox 72"/>
-          <p:cNvSpPr txBox="1"/>
-          <p:nvPr/>
-        </p:nvSpPr>
-        <p:spPr>
-          <a:xfrm>
-            <a:off x="3291840" y="4590288"/>
-            <a:ext cx="1463040" cy="292608"/>
+          <p:cNvPr id="63" name="TextBox 62"/>
+          <p:cNvSpPr txBox="1"/>
+          <p:nvPr/>
+        </p:nvSpPr>
+        <p:spPr>
+          <a:xfrm>
+            <a:off x="4206240" y="4590288"/>
+            <a:ext cx="1645920" cy="292608"/>
           </a:xfrm>
           <a:prstGeom prst="rect">
             <a:avLst/>
@@ -6398,14 +5998,14 @@
       </p:sp>
       <p:sp>
         <p:nvSpPr>
-          <p:cNvPr id="74" name="Rectangle 73"/>
+          <p:cNvPr id="64" name="Rectangle 63"/>
           <p:cNvSpPr/>
           <p:nvPr/>
         </p:nvSpPr>
         <p:spPr>
           <a:xfrm>
-            <a:off x="4754880" y="4526280"/>
-            <a:ext cx="1463040" cy="420624"/>
+            <a:off x="5852160" y="4526280"/>
+            <a:ext cx="1645920" cy="420624"/>
           </a:xfrm>
           <a:prstGeom prst="rect">
             <a:avLst/>
@@ -6443,14 +6043,14 @@
       </p:sp>
       <p:sp>
         <p:nvSpPr>
-          <p:cNvPr id="75" name="TextBox 74"/>
-          <p:cNvSpPr txBox="1"/>
-          <p:nvPr/>
-        </p:nvSpPr>
-        <p:spPr>
-          <a:xfrm>
-            <a:off x="4754880" y="4590288"/>
-            <a:ext cx="1463040" cy="292608"/>
+          <p:cNvPr id="65" name="TextBox 64"/>
+          <p:cNvSpPr txBox="1"/>
+          <p:nvPr/>
+        </p:nvSpPr>
+        <p:spPr>
+          <a:xfrm>
+            <a:off x="5852160" y="4590288"/>
+            <a:ext cx="1645920" cy="292608"/>
           </a:xfrm>
           <a:prstGeom prst="rect">
             <a:avLst/>
@@ -6478,14 +6078,14 @@
       </p:sp>
       <p:sp>
         <p:nvSpPr>
-          <p:cNvPr id="76" name="Rectangle 75"/>
+          <p:cNvPr id="66" name="Rectangle 65"/>
           <p:cNvSpPr/>
           <p:nvPr/>
         </p:nvSpPr>
         <p:spPr>
           <a:xfrm>
-            <a:off x="6217920" y="4526280"/>
-            <a:ext cx="1463040" cy="420624"/>
+            <a:off x="7498080" y="4526280"/>
+            <a:ext cx="1645920" cy="420624"/>
           </a:xfrm>
           <a:prstGeom prst="rect">
             <a:avLst/>
@@ -6523,14 +6123,14 @@
       </p:sp>
       <p:sp>
         <p:nvSpPr>
-          <p:cNvPr id="77" name="TextBox 76"/>
-          <p:cNvSpPr txBox="1"/>
-          <p:nvPr/>
-        </p:nvSpPr>
-        <p:spPr>
-          <a:xfrm>
-            <a:off x="6217920" y="4590288"/>
-            <a:ext cx="1463040" cy="292608"/>
+          <p:cNvPr id="67" name="TextBox 66"/>
+          <p:cNvSpPr txBox="1"/>
+          <p:nvPr/>
+        </p:nvSpPr>
+        <p:spPr>
+          <a:xfrm>
+            <a:off x="7498080" y="4590288"/>
+            <a:ext cx="1645920" cy="292608"/>
           </a:xfrm>
           <a:prstGeom prst="rect">
             <a:avLst/>
@@ -6558,14 +6158,14 @@
       </p:sp>
       <p:sp>
         <p:nvSpPr>
-          <p:cNvPr id="78" name="Rectangle 77"/>
+          <p:cNvPr id="68" name="Rectangle 67"/>
           <p:cNvSpPr/>
           <p:nvPr/>
         </p:nvSpPr>
         <p:spPr>
           <a:xfrm>
-            <a:off x="7680960" y="4526280"/>
-            <a:ext cx="1463040" cy="420624"/>
+            <a:off x="9144000" y="4526280"/>
+            <a:ext cx="1783080" cy="420624"/>
           </a:xfrm>
           <a:prstGeom prst="rect">
             <a:avLst/>
@@ -6603,14 +6203,14 @@
       </p:sp>
       <p:sp>
         <p:nvSpPr>
-          <p:cNvPr id="79" name="TextBox 78"/>
-          <p:cNvSpPr txBox="1"/>
-          <p:nvPr/>
-        </p:nvSpPr>
-        <p:spPr>
-          <a:xfrm>
-            <a:off x="7680960" y="4590288"/>
-            <a:ext cx="1463040" cy="292608"/>
+          <p:cNvPr id="69" name="TextBox 68"/>
+          <p:cNvSpPr txBox="1"/>
+          <p:nvPr/>
+        </p:nvSpPr>
+        <p:spPr>
+          <a:xfrm>
+            <a:off x="9144000" y="4590288"/>
+            <a:ext cx="1783080" cy="292608"/>
           </a:xfrm>
           <a:prstGeom prst="rect">
             <a:avLst/>
@@ -6627,105 +6227,25 @@
             <a:r>
               <a:rPr sz="1400" b="1">
                 <a:solidFill>
-                  <a:srgbClr val="EF4444"/>
-                </a:solidFill>
-                <a:latin typeface="Calibri"/>
-              </a:rPr>
-              <a:t>✗</a:t>
-            </a:r>
-          </a:p>
-        </p:txBody>
-      </p:sp>
-      <p:sp>
-        <p:nvSpPr>
-          <p:cNvPr id="80" name="Rectangle 79"/>
+                  <a:srgbClr val="22C55E"/>
+                </a:solidFill>
+                <a:latin typeface="Calibri"/>
+              </a:rPr>
+              <a:t>✓</a:t>
+            </a:r>
+          </a:p>
+        </p:txBody>
+      </p:sp>
+      <p:sp>
+        <p:nvSpPr>
+          <p:cNvPr id="70" name="Rectangle 69"/>
           <p:cNvSpPr/>
           <p:nvPr/>
         </p:nvSpPr>
         <p:spPr>
           <a:xfrm>
-            <a:off x="9144000" y="4526280"/>
-            <a:ext cx="1737360" cy="420624"/>
-          </a:xfrm>
-          <a:prstGeom prst="rect">
-            <a:avLst/>
-          </a:prstGeom>
-          <a:solidFill>
-            <a:srgbClr val="201900"/>
-          </a:solidFill>
-          <a:ln w="12700">
-            <a:solidFill>
-              <a:srgbClr val="252A40"/>
-            </a:solidFill>
-          </a:ln>
-        </p:spPr>
-        <p:style>
-          <a:lnRef idx="1">
-            <a:schemeClr val="accent1"/>
-          </a:lnRef>
-          <a:fillRef idx="3">
-            <a:schemeClr val="accent1"/>
-          </a:fillRef>
-          <a:effectRef idx="2">
-            <a:schemeClr val="accent1"/>
-          </a:effectRef>
-          <a:fontRef idx="minor">
-            <a:schemeClr val="lt1"/>
-          </a:fontRef>
-        </p:style>
-        <p:txBody>
-          <a:bodyPr rtlCol="0" anchor="ctr"/>
-          <a:lstStyle/>
-          <a:p>
-            <a:pPr algn="ctr"/>
-          </a:p>
-        </p:txBody>
-      </p:sp>
-      <p:sp>
-        <p:nvSpPr>
-          <p:cNvPr id="81" name="TextBox 80"/>
-          <p:cNvSpPr txBox="1"/>
-          <p:nvPr/>
-        </p:nvSpPr>
-        <p:spPr>
-          <a:xfrm>
-            <a:off x="9144000" y="4590288"/>
-            <a:ext cx="1737360" cy="292608"/>
-          </a:xfrm>
-          <a:prstGeom prst="rect">
-            <a:avLst/>
-          </a:prstGeom>
-          <a:noFill/>
-        </p:spPr>
-        <p:txBody>
-          <a:bodyPr wrap="square" lIns="45720" rIns="45720" tIns="18288" bIns="18288">
-            <a:spAutoFit/>
-          </a:bodyPr>
-          <a:lstStyle/>
-          <a:p>
-            <a:pPr algn="ctr"/>
-            <a:r>
-              <a:rPr sz="1400" b="1">
-                <a:solidFill>
-                  <a:srgbClr val="22C55E"/>
-                </a:solidFill>
-                <a:latin typeface="Calibri"/>
-              </a:rPr>
-              <a:t>✓</a:t>
-            </a:r>
-          </a:p>
-        </p:txBody>
-      </p:sp>
-      <p:sp>
-        <p:nvSpPr>
-          <p:cNvPr id="82" name="Rectangle 81"/>
-          <p:cNvSpPr/>
-          <p:nvPr/>
-        </p:nvSpPr>
-        <p:spPr>
-          <a:xfrm>
             <a:off x="365760" y="4946904"/>
-            <a:ext cx="2926080" cy="420624"/>
+            <a:ext cx="3840480" cy="420624"/>
           </a:xfrm>
           <a:prstGeom prst="rect">
             <a:avLst/>
@@ -6763,14 +6283,14 @@
       </p:sp>
       <p:sp>
         <p:nvSpPr>
-          <p:cNvPr id="83" name="TextBox 82"/>
+          <p:cNvPr id="71" name="TextBox 70"/>
           <p:cNvSpPr txBox="1"/>
           <p:nvPr/>
         </p:nvSpPr>
         <p:spPr>
           <a:xfrm>
             <a:off x="457200" y="5038344"/>
-            <a:ext cx="2788920" cy="256032"/>
+            <a:ext cx="3703320" cy="256032"/>
           </a:xfrm>
           <a:prstGeom prst="rect">
             <a:avLst/>
@@ -6791,21 +6311,21 @@
                 </a:solidFill>
                 <a:latin typeface="Calibri"/>
               </a:rPr>
-              <a:t>Single Workspace</a:t>
-            </a:r>
-          </a:p>
-        </p:txBody>
-      </p:sp>
-      <p:sp>
-        <p:nvSpPr>
-          <p:cNvPr id="84" name="Rectangle 83"/>
+              <a:t>Complete research workflow end-to-end</a:t>
+            </a:r>
+          </a:p>
+        </p:txBody>
+      </p:sp>
+      <p:sp>
+        <p:nvSpPr>
+          <p:cNvPr id="72" name="Rectangle 71"/>
           <p:cNvSpPr/>
           <p:nvPr/>
         </p:nvSpPr>
         <p:spPr>
           <a:xfrm>
-            <a:off x="3291840" y="4946904"/>
-            <a:ext cx="1463040" cy="420624"/>
+            <a:off x="4206240" y="4946904"/>
+            <a:ext cx="1645920" cy="420624"/>
           </a:xfrm>
           <a:prstGeom prst="rect">
             <a:avLst/>
@@ -6843,14 +6363,14 @@
       </p:sp>
       <p:sp>
         <p:nvSpPr>
-          <p:cNvPr id="85" name="TextBox 84"/>
-          <p:cNvSpPr txBox="1"/>
-          <p:nvPr/>
-        </p:nvSpPr>
-        <p:spPr>
-          <a:xfrm>
-            <a:off x="3291840" y="5010912"/>
-            <a:ext cx="1463040" cy="292608"/>
+          <p:cNvPr id="73" name="TextBox 72"/>
+          <p:cNvSpPr txBox="1"/>
+          <p:nvPr/>
+        </p:nvSpPr>
+        <p:spPr>
+          <a:xfrm>
+            <a:off x="4206240" y="5010912"/>
+            <a:ext cx="1645920" cy="292608"/>
           </a:xfrm>
           <a:prstGeom prst="rect">
             <a:avLst/>
@@ -6878,14 +6398,14 @@
       </p:sp>
       <p:sp>
         <p:nvSpPr>
-          <p:cNvPr id="86" name="Rectangle 85"/>
+          <p:cNvPr id="74" name="Rectangle 73"/>
           <p:cNvSpPr/>
           <p:nvPr/>
         </p:nvSpPr>
         <p:spPr>
           <a:xfrm>
-            <a:off x="4754880" y="4946904"/>
-            <a:ext cx="1463040" cy="420624"/>
+            <a:off x="5852160" y="4946904"/>
+            <a:ext cx="1645920" cy="420624"/>
           </a:xfrm>
           <a:prstGeom prst="rect">
             <a:avLst/>
@@ -6923,14 +6443,14 @@
       </p:sp>
       <p:sp>
         <p:nvSpPr>
-          <p:cNvPr id="87" name="TextBox 86"/>
-          <p:cNvSpPr txBox="1"/>
-          <p:nvPr/>
-        </p:nvSpPr>
-        <p:spPr>
-          <a:xfrm>
-            <a:off x="4754880" y="5010912"/>
-            <a:ext cx="1463040" cy="292608"/>
+          <p:cNvPr id="75" name="TextBox 74"/>
+          <p:cNvSpPr txBox="1"/>
+          <p:nvPr/>
+        </p:nvSpPr>
+        <p:spPr>
+          <a:xfrm>
+            <a:off x="5852160" y="5010912"/>
+            <a:ext cx="1645920" cy="292608"/>
           </a:xfrm>
           <a:prstGeom prst="rect">
             <a:avLst/>
@@ -6958,14 +6478,14 @@
       </p:sp>
       <p:sp>
         <p:nvSpPr>
-          <p:cNvPr id="88" name="Rectangle 87"/>
+          <p:cNvPr id="76" name="Rectangle 75"/>
           <p:cNvSpPr/>
           <p:nvPr/>
         </p:nvSpPr>
         <p:spPr>
           <a:xfrm>
-            <a:off x="6217920" y="4946904"/>
-            <a:ext cx="1463040" cy="420624"/>
+            <a:off x="7498080" y="4946904"/>
+            <a:ext cx="1645920" cy="420624"/>
           </a:xfrm>
           <a:prstGeom prst="rect">
             <a:avLst/>
@@ -7003,14 +6523,14 @@
       </p:sp>
       <p:sp>
         <p:nvSpPr>
-          <p:cNvPr id="89" name="TextBox 88"/>
-          <p:cNvSpPr txBox="1"/>
-          <p:nvPr/>
-        </p:nvSpPr>
-        <p:spPr>
-          <a:xfrm>
-            <a:off x="6217920" y="5010912"/>
-            <a:ext cx="1463040" cy="292608"/>
+          <p:cNvPr id="77" name="TextBox 76"/>
+          <p:cNvSpPr txBox="1"/>
+          <p:nvPr/>
+        </p:nvSpPr>
+        <p:spPr>
+          <a:xfrm>
+            <a:off x="7498080" y="5010912"/>
+            <a:ext cx="1645920" cy="292608"/>
           </a:xfrm>
           <a:prstGeom prst="rect">
             <a:avLst/>
@@ -7038,14 +6558,14 @@
       </p:sp>
       <p:sp>
         <p:nvSpPr>
-          <p:cNvPr id="90" name="Rectangle 89"/>
+          <p:cNvPr id="78" name="Rectangle 77"/>
           <p:cNvSpPr/>
           <p:nvPr/>
         </p:nvSpPr>
         <p:spPr>
           <a:xfrm>
-            <a:off x="7680960" y="4946904"/>
-            <a:ext cx="1463040" cy="420624"/>
+            <a:off x="9144000" y="4946904"/>
+            <a:ext cx="1783080" cy="420624"/>
           </a:xfrm>
           <a:prstGeom prst="rect">
             <a:avLst/>
@@ -7083,14 +6603,14 @@
       </p:sp>
       <p:sp>
         <p:nvSpPr>
-          <p:cNvPr id="91" name="TextBox 90"/>
-          <p:cNvSpPr txBox="1"/>
-          <p:nvPr/>
-        </p:nvSpPr>
-        <p:spPr>
-          <a:xfrm>
-            <a:off x="7680960" y="5010912"/>
-            <a:ext cx="1463040" cy="292608"/>
+          <p:cNvPr id="79" name="TextBox 78"/>
+          <p:cNvSpPr txBox="1"/>
+          <p:nvPr/>
+        </p:nvSpPr>
+        <p:spPr>
+          <a:xfrm>
+            <a:off x="9144000" y="5010912"/>
+            <a:ext cx="1783080" cy="292608"/>
           </a:xfrm>
           <a:prstGeom prst="rect">
             <a:avLst/>
@@ -7107,86 +6627,6 @@
             <a:r>
               <a:rPr sz="1400" b="1">
                 <a:solidFill>
-                  <a:srgbClr val="EF4444"/>
-                </a:solidFill>
-                <a:latin typeface="Calibri"/>
-              </a:rPr>
-              <a:t>✗</a:t>
-            </a:r>
-          </a:p>
-        </p:txBody>
-      </p:sp>
-      <p:sp>
-        <p:nvSpPr>
-          <p:cNvPr id="92" name="Rectangle 91"/>
-          <p:cNvSpPr/>
-          <p:nvPr/>
-        </p:nvSpPr>
-        <p:spPr>
-          <a:xfrm>
-            <a:off x="9144000" y="4946904"/>
-            <a:ext cx="1737360" cy="420624"/>
-          </a:xfrm>
-          <a:prstGeom prst="rect">
-            <a:avLst/>
-          </a:prstGeom>
-          <a:solidFill>
-            <a:srgbClr val="201900"/>
-          </a:solidFill>
-          <a:ln w="12700">
-            <a:solidFill>
-              <a:srgbClr val="252A40"/>
-            </a:solidFill>
-          </a:ln>
-        </p:spPr>
-        <p:style>
-          <a:lnRef idx="1">
-            <a:schemeClr val="accent1"/>
-          </a:lnRef>
-          <a:fillRef idx="3">
-            <a:schemeClr val="accent1"/>
-          </a:fillRef>
-          <a:effectRef idx="2">
-            <a:schemeClr val="accent1"/>
-          </a:effectRef>
-          <a:fontRef idx="minor">
-            <a:schemeClr val="lt1"/>
-          </a:fontRef>
-        </p:style>
-        <p:txBody>
-          <a:bodyPr rtlCol="0" anchor="ctr"/>
-          <a:lstStyle/>
-          <a:p>
-            <a:pPr algn="ctr"/>
-          </a:p>
-        </p:txBody>
-      </p:sp>
-      <p:sp>
-        <p:nvSpPr>
-          <p:cNvPr id="93" name="TextBox 92"/>
-          <p:cNvSpPr txBox="1"/>
-          <p:nvPr/>
-        </p:nvSpPr>
-        <p:spPr>
-          <a:xfrm>
-            <a:off x="9144000" y="5010912"/>
-            <a:ext cx="1737360" cy="292608"/>
-          </a:xfrm>
-          <a:prstGeom prst="rect">
-            <a:avLst/>
-          </a:prstGeom>
-          <a:noFill/>
-        </p:spPr>
-        <p:txBody>
-          <a:bodyPr wrap="square" lIns="45720" rIns="45720" tIns="18288" bIns="18288">
-            <a:spAutoFit/>
-          </a:bodyPr>
-          <a:lstStyle/>
-          <a:p>
-            <a:pPr algn="ctr"/>
-            <a:r>
-              <a:rPr sz="1400" b="1">
-                <a:solidFill>
                   <a:srgbClr val="22C55E"/>
                 </a:solidFill>
                 <a:latin typeface="Calibri"/>
@@ -7198,7 +6638,7 @@
       </p:sp>
       <p:sp>
         <p:nvSpPr>
-          <p:cNvPr id="94" name="Rectangle 93"/>
+          <p:cNvPr id="80" name="Rectangle 79"/>
           <p:cNvSpPr/>
           <p:nvPr/>
         </p:nvSpPr>
@@ -7243,7 +6683,7 @@
       </p:sp>
       <p:sp>
         <p:nvSpPr>
-          <p:cNvPr id="95" name="TextBox 94"/>
+          <p:cNvPr id="81" name="TextBox 80"/>
           <p:cNvSpPr txBox="1"/>
           <p:nvPr/>
         </p:nvSpPr>
@@ -7271,14 +6711,14 @@
                 </a:solidFill>
                 <a:latin typeface="Calibri"/>
               </a:rPr>
-              <a:t>💡  Dynamo AI brings Research, Writing, Citations, Memory and Presentations under one login — built for the academic workflow.</a:t>
-            </a:r>
-          </a:p>
-        </p:txBody>
-      </p:sp>
-      <p:sp>
-        <p:nvSpPr>
-          <p:cNvPr id="96" name="TextBox 95"/>
+              <a:t>💡  Dynamo AI is the only platform where a researcher can complete their entire workflow — without switching tools.</a:t>
+            </a:r>
+          </a:p>
+        </p:txBody>
+      </p:sp>
+      <p:sp>
+        <p:nvSpPr>
+          <p:cNvPr id="82" name="TextBox 81"/>
           <p:cNvSpPr txBox="1"/>
           <p:nvPr/>
         </p:nvSpPr>
@@ -7313,7 +6753,7 @@
       </p:sp>
       <p:sp>
         <p:nvSpPr>
-          <p:cNvPr id="97" name="TextBox 96"/>
+          <p:cNvPr id="83" name="TextBox 82"/>
           <p:cNvSpPr txBox="1"/>
           <p:nvPr/>
         </p:nvSpPr>
@@ -8911,7 +8351,7 @@
                 </a:solidFill>
                 <a:latin typeface="Calibri"/>
               </a:rPr>
-              <a:t>All researchers, educators &amp; students using digital tools across India.</a:t>
+              <a:t>Researchers, educators and institutions across India using digital academic tools.</a:t>
             </a:r>
           </a:p>
         </p:txBody>
@@ -8946,7 +8386,7 @@
                 </a:solidFill>
                 <a:latin typeface="Calibri"/>
               </a:rPr>
-              <a:t>₹2,400 Cr+</a:t>
+              <a:t>India-wide</a:t>
             </a:r>
           </a:p>
         </p:txBody>
@@ -8981,7 +8421,7 @@
                 </a:solidFill>
                 <a:latin typeface="Calibri"/>
               </a:rPr>
-              <a:t>estimated annual academic productivity market (India)</a:t>
+              <a:t>academic research &amp; education sector</a:t>
             </a:r>
           </a:p>
         </p:txBody>
@@ -11079,7 +10519,7 @@
                 </a:solidFill>
                 <a:latin typeface="Calibri"/>
               </a:rPr>
-              <a:t>• Priority speed &amp; support</a:t>
+              <a:t>• Advanced academic workflows</a:t>
             </a:r>
           </a:p>
         </p:txBody>
@@ -14143,7 +13583,7 @@
                 </a:solidFill>
                 <a:latin typeface="Calibri"/>
               </a:rPr>
-              <a:t>›  Series A fundraising</a:t>
+              <a:t>›  National Academic Adoption</a:t>
             </a:r>
           </a:p>
         </p:txBody>
@@ -15361,42 +14801,122 @@
       </p:sp>
       <p:sp>
         <p:nvSpPr>
-          <p:cNvPr id="32" name="TextBox 31"/>
-          <p:cNvSpPr txBox="1"/>
-          <p:nvPr/>
-        </p:nvSpPr>
-        <p:spPr>
-          <a:xfrm>
-            <a:off x="4206240" y="5577840"/>
-            <a:ext cx="8001000" cy="502920"/>
-          </a:xfrm>
-          <a:prstGeom prst="rect">
-            <a:avLst/>
-          </a:prstGeom>
-          <a:noFill/>
-        </p:spPr>
-        <p:txBody>
-          <a:bodyPr wrap="square" lIns="45720" rIns="45720" tIns="18288" bIns="18288">
-            <a:spAutoFit/>
-          </a:bodyPr>
-          <a:lstStyle/>
-          <a:p>
-            <a:pPr algn="l"/>
-            <a:r>
-              <a:rPr sz="1100" b="0">
-                <a:solidFill>
-                  <a:srgbClr val="AAAABB"/>
-                </a:solidFill>
-                <a:latin typeface="Calibri"/>
-              </a:rPr>
-              <a:t>Founded Dynamo AI after seeing first-hand how fragmented academic tools were stealing thousands of hours from researchers across India.</a:t>
-            </a:r>
+          <p:cNvPr id="32" name="Rectangle 31"/>
+          <p:cNvSpPr/>
+          <p:nvPr/>
+        </p:nvSpPr>
+        <p:spPr>
+          <a:xfrm>
+            <a:off x="4206240" y="5257800"/>
+            <a:ext cx="8001000" cy="1234440"/>
+          </a:xfrm>
+          <a:prstGeom prst="rect">
+            <a:avLst/>
+          </a:prstGeom>
+          <a:solidFill>
+            <a:srgbClr val="121728"/>
+          </a:solidFill>
+          <a:ln w="12700">
+            <a:solidFill>
+              <a:srgbClr val="252A40"/>
+            </a:solidFill>
+          </a:ln>
+        </p:spPr>
+        <p:style>
+          <a:lnRef idx="1">
+            <a:schemeClr val="accent1"/>
+          </a:lnRef>
+          <a:fillRef idx="3">
+            <a:schemeClr val="accent1"/>
+          </a:fillRef>
+          <a:effectRef idx="2">
+            <a:schemeClr val="accent1"/>
+          </a:effectRef>
+          <a:fontRef idx="minor">
+            <a:schemeClr val="lt1"/>
+          </a:fontRef>
+        </p:style>
+        <p:txBody>
+          <a:bodyPr rtlCol="0" anchor="ctr"/>
+          <a:lstStyle/>
+          <a:p>
+            <a:pPr algn="ctr"/>
           </a:p>
         </p:txBody>
       </p:sp>
       <p:sp>
         <p:nvSpPr>
           <p:cNvPr id="33" name="TextBox 32"/>
+          <p:cNvSpPr txBox="1"/>
+          <p:nvPr/>
+        </p:nvSpPr>
+        <p:spPr>
+          <a:xfrm>
+            <a:off x="4343400" y="5376672"/>
+            <a:ext cx="4572000" cy="228600"/>
+          </a:xfrm>
+          <a:prstGeom prst="rect">
+            <a:avLst/>
+          </a:prstGeom>
+          <a:noFill/>
+        </p:spPr>
+        <p:txBody>
+          <a:bodyPr wrap="square" lIns="45720" rIns="45720" tIns="18288" bIns="18288">
+            <a:spAutoFit/>
+          </a:bodyPr>
+          <a:lstStyle/>
+          <a:p>
+            <a:pPr algn="l"/>
+            <a:r>
+              <a:rPr sz="900" b="1">
+                <a:solidFill>
+                  <a:srgbClr val="FFC107"/>
+                </a:solidFill>
+                <a:latin typeface="Calibri"/>
+              </a:rPr>
+              <a:t>WHY I BUILT DYNAMO AI</a:t>
+            </a:r>
+          </a:p>
+        </p:txBody>
+      </p:sp>
+      <p:sp>
+        <p:nvSpPr>
+          <p:cNvPr id="34" name="TextBox 33"/>
+          <p:cNvSpPr txBox="1"/>
+          <p:nvPr/>
+        </p:nvSpPr>
+        <p:spPr>
+          <a:xfrm>
+            <a:off x="4343400" y="5623560"/>
+            <a:ext cx="7680960" cy="804672"/>
+          </a:xfrm>
+          <a:prstGeom prst="rect">
+            <a:avLst/>
+          </a:prstGeom>
+          <a:noFill/>
+        </p:spPr>
+        <p:txBody>
+          <a:bodyPr wrap="square" lIns="45720" rIns="45720" tIns="18288" bIns="18288">
+            <a:spAutoFit/>
+          </a:bodyPr>
+          <a:lstStyle/>
+          <a:p>
+            <a:pPr algn="l"/>
+            <a:r>
+              <a:rPr sz="1000" b="0">
+                <a:solidFill>
+                  <a:srgbClr val="FFFFFF"/>
+                </a:solidFill>
+                <a:latin typeface="Calibri"/>
+              </a:rPr>
+              <a:t>I experienced how fragmented academic workflows force researchers to spend more time managing tools than producing insight. Dynamo AI was created to unify research, writing, citations and knowledge management into a single academic workspace — so scholars can focus on what actually matters.</a:t>
+            </a:r>
+          </a:p>
+        </p:txBody>
+      </p:sp>
+      <p:sp>
+        <p:nvSpPr>
+          <p:cNvPr id="35" name="TextBox 34"/>
           <p:cNvSpPr txBox="1"/>
           <p:nvPr/>
         </p:nvSpPr>
@@ -15431,7 +14951,7 @@
       </p:sp>
       <p:sp>
         <p:nvSpPr>
-          <p:cNvPr id="34" name="TextBox 33"/>
+          <p:cNvPr id="36" name="TextBox 35"/>
           <p:cNvSpPr txBox="1"/>
           <p:nvPr/>
         </p:nvSpPr>
@@ -19473,28 +18993,28 @@
         <p:spPr>
           <a:xfrm>
             <a:off x="365760" y="1234440"/>
-            <a:ext cx="9144000" cy="685800"/>
-          </a:xfrm>
-          <a:prstGeom prst="rect">
-            <a:avLst/>
-          </a:prstGeom>
-          <a:noFill/>
-        </p:spPr>
-        <p:txBody>
-          <a:bodyPr wrap="square" lIns="45720" rIns="45720" tIns="18288" bIns="18288">
-            <a:spAutoFit/>
-          </a:bodyPr>
-          <a:lstStyle/>
-          <a:p>
-            <a:pPr algn="l"/>
-            <a:r>
-              <a:rPr sz="3800" b="1">
+            <a:ext cx="10058400" cy="685800"/>
+          </a:xfrm>
+          <a:prstGeom prst="rect">
+            <a:avLst/>
+          </a:prstGeom>
+          <a:noFill/>
+        </p:spPr>
+        <p:txBody>
+          <a:bodyPr wrap="square" lIns="45720" rIns="45720" tIns="18288" bIns="18288">
+            <a:spAutoFit/>
+          </a:bodyPr>
+          <a:lstStyle/>
+          <a:p>
+            <a:pPr algn="l"/>
+            <a:r>
+              <a:rPr sz="3600" b="1">
                 <a:solidFill>
                   <a:srgbClr val="FFFFFF"/>
                 </a:solidFill>
                 <a:latin typeface="Calibri"/>
               </a:rPr>
-              <a:t>One platform. Six superpowers.</a:t>
+              <a:t>One platform. One continuous academic workflow.</a:t>
             </a:r>
           </a:p>
         </p:txBody>
@@ -19508,7 +19028,7 @@
         <p:spPr>
           <a:xfrm>
             <a:off x="365760" y="1920240"/>
-            <a:ext cx="8686800" cy="365760"/>
+            <a:ext cx="10058400" cy="365760"/>
           </a:xfrm>
           <a:prstGeom prst="rect">
             <a:avLst/>
@@ -19529,7 +19049,7 @@
                 </a:solidFill>
                 <a:latin typeface="Calibri"/>
               </a:rPr>
-              <a:t>Dynamo AI replaces 6+ disconnected tools with a single intelligent platform built for academics.</a:t>
+              <a:t>Every step of your research — from discovery to final presentation — happens in one place.</a:t>
             </a:r>
           </a:p>
         </p:txBody>
@@ -19609,7 +19129,7 @@
                 </a:solidFill>
                 <a:latin typeface="Calibri"/>
               </a:rPr>
-              <a:t>🔬  Research Discovery</a:t>
+              <a:t>🔬  Discover relevant papers and evidence instantly</a:t>
             </a:r>
           </a:p>
         </p:txBody>
@@ -19644,7 +19164,7 @@
                 </a:solidFill>
                 <a:latin typeface="Calibri"/>
               </a:rPr>
-              <a:t>Real-time search across web + Semantic Scholar</a:t>
+              <a:t>Search across web + Semantic Scholar in seconds — no tab switching</a:t>
             </a:r>
           </a:p>
         </p:txBody>
@@ -19724,7 +19244,7 @@
                 </a:solidFill>
                 <a:latin typeface="Calibri"/>
               </a:rPr>
-              <a:t>📖  Literature Analysis</a:t>
+              <a:t>📖  Identify insights, patterns and research gaps</a:t>
             </a:r>
           </a:p>
         </p:txBody>
@@ -19759,7 +19279,7 @@
                 </a:solidFill>
                 <a:latin typeface="Calibri"/>
               </a:rPr>
-              <a:t>Find gaps, summarise papers, surface insights</a:t>
+              <a:t>Analyse and summarise papers automatically, surface what matters</a:t>
             </a:r>
           </a:p>
         </p:txBody>
@@ -19839,7 +19359,7 @@
                 </a:solidFill>
                 <a:latin typeface="Calibri"/>
               </a:rPr>
-              <a:t>✍️  Academic Writing</a:t>
+              <a:t>✍️  Draft academic content with structured assistance</a:t>
             </a:r>
           </a:p>
         </p:txBody>
@@ -19874,7 +19394,7 @@
                 </a:solidFill>
                 <a:latin typeface="Calibri"/>
               </a:rPr>
-              <a:t>Draft &amp; refine with DeepThink AI mode</a:t>
+              <a:t>Write with DeepThink AI — built for academic rigour and depth</a:t>
             </a:r>
           </a:p>
         </p:txBody>
@@ -19954,7 +19474,7 @@
                 </a:solidFill>
                 <a:latin typeface="Calibri"/>
               </a:rPr>
-              <a:t>📋  Citation Generation</a:t>
+              <a:t>📋  Generate publication-ready citations automatically</a:t>
             </a:r>
           </a:p>
         </p:txBody>
@@ -19989,7 +19509,7 @@
                 </a:solidFill>
                 <a:latin typeface="Calibri"/>
               </a:rPr>
-              <a:t>Auto-format APA, MLA, IEEE, Chicago, Harvard, Vancouver</a:t>
+              <a:t>APA, MLA, IEEE, Chicago, Harvard, Vancouver — formatted on demand</a:t>
             </a:r>
           </a:p>
         </p:txBody>
@@ -20069,7 +19589,7 @@
                 </a:solidFill>
                 <a:latin typeface="Calibri"/>
               </a:rPr>
-              <a:t>📊  Presentation Creation</a:t>
+              <a:t>📊  Convert research into presentations, mind maps and flowcharts</a:t>
             </a:r>
           </a:p>
         </p:txBody>
@@ -20104,7 +19624,7 @@
                 </a:solidFill>
                 <a:latin typeface="Calibri"/>
               </a:rPr>
-              <a:t>Mindmaps, flowcharts, decks — instantly</a:t>
+              <a:t>Go from notes to polished deck or visual in minutes</a:t>
             </a:r>
           </a:p>
         </p:txBody>
@@ -20184,7 +19704,7 @@
                 </a:solidFill>
                 <a:latin typeface="Calibri"/>
               </a:rPr>
-              <a:t>🧠  Knowledge Management</a:t>
+              <a:t>🧠  Preserve research context across documents and sessions</a:t>
             </a:r>
           </a:p>
         </p:txBody>
@@ -20219,7 +19739,7 @@
                 </a:solidFill>
                 <a:latin typeface="Calibri"/>
               </a:rPr>
-              <a:t>AI Memory + Document Library, persistent across chats</a:t>
+              <a:t>AI Memory + Document Library keep your work accessible — always</a:t>
             </a:r>
           </a:p>
         </p:txBody>
@@ -23927,7 +23447,7 @@
                 </a:solidFill>
                 <a:latin typeface="Calibri"/>
               </a:rPr>
-              <a:t>AI Memory and Document Library make Dynamo the first AI that actually knows your research context — chat after chat.</a:t>
+              <a:t>Your research context persists across sessions, documents and projects.</a:t>
             </a:r>
           </a:p>
         </p:txBody>
@@ -24420,7 +23940,7 @@
                 </a:solidFill>
                 <a:latin typeface="Calibri"/>
               </a:rPr>
-              <a:t>AI Memory</a:t>
+              <a:t>AI Memory — Research Context Retention</a:t>
             </a:r>
           </a:p>
         </p:txBody>
@@ -24455,7 +23975,7 @@
                 </a:solidFill>
                 <a:latin typeface="Calibri"/>
               </a:rPr>
-              <a:t>Auto-captured facts about your research interests, goals &amp; topics</a:t>
+              <a:t>Dynamo remembers your topics, goals &amp; interests across every session</a:t>
             </a:r>
           </a:p>
         </p:txBody>
@@ -24719,7 +24239,7 @@
                 </a:solidFill>
                 <a:latin typeface="Calibri"/>
               </a:rPr>
-              <a:t>PDFs · DOCX · TXT — summaries injected into every chat</a:t>
+              <a:t>Access all research materials in one place — summaries injected into every chat</a:t>
             </a:r>
           </a:p>
         </p:txBody>
@@ -24754,7 +24274,7 @@
                 </a:solidFill>
                 <a:latin typeface="Calibri"/>
               </a:rPr>
-              <a:t>Built-in differentiator: no other academic AI tool today has both persistent Memory AND a Document Library.</a:t>
+              <a:t>Your research context remains available across sessions, projects and uploaded documents — automatically.</a:t>
             </a:r>
           </a:p>
         </p:txBody>
@@ -24944,7 +24464,7 @@
                 </a:solidFill>
                 <a:latin typeface="Calibri"/>
               </a:rPr>
-              <a:t>WATCH IT WORK</a:t>
+              <a:t>THE JOURNEY</a:t>
             </a:r>
           </a:p>
         </p:txBody>
@@ -24993,7 +24513,7 @@
         <p:spPr>
           <a:xfrm>
             <a:off x="365760" y="868680"/>
-            <a:ext cx="1572768" cy="274320"/>
+            <a:ext cx="2578608" cy="274320"/>
           </a:xfrm>
           <a:prstGeom prst="rect">
             <a:avLst/>
@@ -25038,7 +24558,7 @@
         <p:spPr>
           <a:xfrm>
             <a:off x="411480" y="877824"/>
-            <a:ext cx="1481328" cy="256032"/>
+            <a:ext cx="2487168" cy="256032"/>
           </a:xfrm>
           <a:prstGeom prst="rect">
             <a:avLst/>
@@ -25059,7 +24579,7 @@
                 </a:solidFill>
                 <a:latin typeface="Calibri"/>
               </a:rPr>
-              <a:t>● PRODUCT DEMO</a:t>
+              <a:t>● THE RESEARCHER JOURNEY</a:t>
             </a:r>
           </a:p>
         </p:txBody>
@@ -25073,28 +24593,28 @@
         <p:spPr>
           <a:xfrm>
             <a:off x="365760" y="1234440"/>
-            <a:ext cx="9144000" cy="640080"/>
-          </a:xfrm>
-          <a:prstGeom prst="rect">
-            <a:avLst/>
-          </a:prstGeom>
-          <a:noFill/>
-        </p:spPr>
-        <p:txBody>
-          <a:bodyPr wrap="square" lIns="45720" rIns="45720" tIns="18288" bIns="18288">
-            <a:spAutoFit/>
-          </a:bodyPr>
-          <a:lstStyle/>
-          <a:p>
-            <a:pPr algn="l"/>
-            <a:r>
-              <a:rPr sz="3600" b="1">
+            <a:ext cx="10972800" cy="640080"/>
+          </a:xfrm>
+          <a:prstGeom prst="rect">
+            <a:avLst/>
+          </a:prstGeom>
+          <a:noFill/>
+        </p:spPr>
+        <p:txBody>
+          <a:bodyPr wrap="square" lIns="45720" rIns="45720" tIns="18288" bIns="18288">
+            <a:spAutoFit/>
+          </a:bodyPr>
+          <a:lstStyle/>
+          <a:p>
+            <a:pPr algn="l"/>
+            <a:r>
+              <a:rPr sz="3200" b="1">
                 <a:solidFill>
                   <a:srgbClr val="FFFFFF"/>
                 </a:solidFill>
                 <a:latin typeface="Calibri"/>
               </a:rPr>
-              <a:t>See Dynamo AI in 90 seconds.</a:t>
+              <a:t>The same workflow. A completely different experience.</a:t>
             </a:r>
           </a:p>
         </p:txBody>
@@ -25108,28 +24628,28 @@
         <p:spPr>
           <a:xfrm>
             <a:off x="365760" y="1874519"/>
-            <a:ext cx="10058400" cy="365760"/>
-          </a:xfrm>
-          <a:prstGeom prst="rect">
-            <a:avLst/>
-          </a:prstGeom>
-          <a:noFill/>
-        </p:spPr>
-        <p:txBody>
-          <a:bodyPr wrap="square" lIns="45720" rIns="45720" tIns="18288" bIns="18288">
-            <a:spAutoFit/>
-          </a:bodyPr>
-          <a:lstStyle/>
-          <a:p>
-            <a:pPr algn="l"/>
-            <a:r>
-              <a:rPr sz="1400" b="0">
+            <a:ext cx="10972800" cy="347472"/>
+          </a:xfrm>
+          <a:prstGeom prst="rect">
+            <a:avLst/>
+          </a:prstGeom>
+          <a:noFill/>
+        </p:spPr>
+        <p:txBody>
+          <a:bodyPr wrap="square" lIns="45720" rIns="45720" tIns="18288" bIns="18288">
+            <a:spAutoFit/>
+          </a:bodyPr>
+          <a:lstStyle/>
+          <a:p>
+            <a:pPr algn="l"/>
+            <a:r>
+              <a:rPr sz="1300" b="0">
                 <a:solidFill>
                   <a:srgbClr val="AAAABB"/>
                 </a:solidFill>
                 <a:latin typeface="Calibri"/>
               </a:rPr>
-              <a:t>A full end-to-end walkthrough — from research question to finished deck.</a:t>
+              <a:t>Dynamo AI doesn't add another tool. It replaces the entire fragmented workflow with one.</a:t>
             </a:r>
           </a:p>
         </p:txBody>
@@ -25142,18 +24662,18 @@
         </p:nvSpPr>
         <p:spPr>
           <a:xfrm>
-            <a:off x="2194560" y="2468880"/>
-            <a:ext cx="7772400" cy="3291840"/>
+            <a:off x="365760" y="2331720"/>
+            <a:ext cx="5303520" cy="4160520"/>
           </a:xfrm>
           <a:prstGeom prst="rect">
             <a:avLst/>
           </a:prstGeom>
           <a:solidFill>
-            <a:srgbClr val="0A0E1A"/>
+            <a:srgbClr val="140808"/>
           </a:solidFill>
-          <a:ln w="38100">
+          <a:ln w="12700">
             <a:solidFill>
-              <a:srgbClr val="FFC107"/>
+              <a:srgbClr val="EF4444"/>
             </a:solidFill>
           </a:ln>
         </p:spPr>
@@ -25181,24 +24701,94 @@
       </p:sp>
       <p:sp>
         <p:nvSpPr>
-          <p:cNvPr id="11" name="Rectangle 10"/>
+          <p:cNvPr id="11" name="TextBox 10"/>
+          <p:cNvSpPr txBox="1"/>
+          <p:nvPr/>
+        </p:nvSpPr>
+        <p:spPr>
+          <a:xfrm>
+            <a:off x="548640" y="2468880"/>
+            <a:ext cx="5029200" cy="256032"/>
+          </a:xfrm>
+          <a:prstGeom prst="rect">
+            <a:avLst/>
+          </a:prstGeom>
+          <a:noFill/>
+        </p:spPr>
+        <p:txBody>
+          <a:bodyPr wrap="square" lIns="45720" rIns="45720" tIns="18288" bIns="18288">
+            <a:spAutoFit/>
+          </a:bodyPr>
+          <a:lstStyle/>
+          <a:p>
+            <a:pPr algn="l"/>
+            <a:r>
+              <a:rPr sz="900" b="1">
+                <a:solidFill>
+                  <a:srgbClr val="EF4444"/>
+                </a:solidFill>
+                <a:latin typeface="Calibri"/>
+              </a:rPr>
+              <a:t>✗  WITHOUT DYNAMO AI</a:t>
+            </a:r>
+          </a:p>
+        </p:txBody>
+      </p:sp>
+      <p:sp>
+        <p:nvSpPr>
+          <p:cNvPr id="12" name="TextBox 11"/>
+          <p:cNvSpPr txBox="1"/>
+          <p:nvPr/>
+        </p:nvSpPr>
+        <p:spPr>
+          <a:xfrm>
+            <a:off x="548640" y="2743200"/>
+            <a:ext cx="5029200" cy="256032"/>
+          </a:xfrm>
+          <a:prstGeom prst="rect">
+            <a:avLst/>
+          </a:prstGeom>
+          <a:noFill/>
+        </p:spPr>
+        <p:txBody>
+          <a:bodyPr wrap="square" lIns="45720" rIns="45720" tIns="18288" bIns="18288">
+            <a:spAutoFit/>
+          </a:bodyPr>
+          <a:lstStyle/>
+          <a:p>
+            <a:pPr algn="l"/>
+            <a:r>
+              <a:rPr sz="1000" b="0">
+                <a:solidFill>
+                  <a:srgbClr val="AAAABB"/>
+                </a:solidFill>
+                <a:latin typeface="Calibri"/>
+              </a:rPr>
+              <a:t>Multiple tools. Fragmented workflow.</a:t>
+            </a:r>
+          </a:p>
+        </p:txBody>
+      </p:sp>
+      <p:sp>
+        <p:nvSpPr>
+          <p:cNvPr id="13" name="Rectangle 12"/>
           <p:cNvSpPr/>
           <p:nvPr/>
         </p:nvSpPr>
         <p:spPr>
           <a:xfrm>
-            <a:off x="2331720" y="2606040"/>
-            <a:ext cx="7498080" cy="3017520"/>
+            <a:off x="548640" y="3108960"/>
+            <a:ext cx="4937760" cy="438912"/>
           </a:xfrm>
           <a:prstGeom prst="rect">
             <a:avLst/>
           </a:prstGeom>
           <a:solidFill>
-            <a:srgbClr val="14192B"/>
+            <a:srgbClr val="201010"/>
           </a:solidFill>
           <a:ln w="12700">
             <a:solidFill>
-              <a:srgbClr val="252A40"/>
+              <a:srgbClr val="552020"/>
             </a:solidFill>
           </a:ln>
         </p:spPr>
@@ -25226,23 +24816,130 @@
       </p:sp>
       <p:sp>
         <p:nvSpPr>
-          <p:cNvPr id="12" name="Oval 11"/>
+          <p:cNvPr id="14" name="TextBox 13"/>
+          <p:cNvSpPr txBox="1"/>
+          <p:nvPr/>
+        </p:nvSpPr>
+        <p:spPr>
+          <a:xfrm>
+            <a:off x="658368" y="3145536"/>
+            <a:ext cx="2011680" cy="228600"/>
+          </a:xfrm>
+          <a:prstGeom prst="rect">
+            <a:avLst/>
+          </a:prstGeom>
+          <a:noFill/>
+        </p:spPr>
+        <p:txBody>
+          <a:bodyPr wrap="square" lIns="45720" rIns="45720" tIns="18288" bIns="18288">
+            <a:spAutoFit/>
+          </a:bodyPr>
+          <a:lstStyle/>
+          <a:p>
+            <a:pPr algn="l"/>
+            <a:r>
+              <a:rPr sz="1100" b="1">
+                <a:solidFill>
+                  <a:srgbClr val="FFFFFF"/>
+                </a:solidFill>
+                <a:latin typeface="Calibri"/>
+              </a:rPr>
+              <a:t>→  Search Papers</a:t>
+            </a:r>
+          </a:p>
+        </p:txBody>
+      </p:sp>
+      <p:sp>
+        <p:nvSpPr>
+          <p:cNvPr id="15" name="TextBox 14"/>
+          <p:cNvSpPr txBox="1"/>
+          <p:nvPr/>
+        </p:nvSpPr>
+        <p:spPr>
+          <a:xfrm>
+            <a:off x="658368" y="3346704"/>
+            <a:ext cx="2743200" cy="182880"/>
+          </a:xfrm>
+          <a:prstGeom prst="rect">
+            <a:avLst/>
+          </a:prstGeom>
+          <a:noFill/>
+        </p:spPr>
+        <p:txBody>
+          <a:bodyPr wrap="square" lIns="45720" rIns="45720" tIns="18288" bIns="18288">
+            <a:spAutoFit/>
+          </a:bodyPr>
+          <a:lstStyle/>
+          <a:p>
+            <a:pPr algn="l"/>
+            <a:r>
+              <a:rPr sz="800" b="0">
+                <a:solidFill>
+                  <a:srgbClr val="EF4444"/>
+                </a:solidFill>
+                <a:latin typeface="Calibri"/>
+              </a:rPr>
+              <a:t>Google Scholar, databases</a:t>
+            </a:r>
+          </a:p>
+        </p:txBody>
+      </p:sp>
+      <p:sp>
+        <p:nvSpPr>
+          <p:cNvPr id="16" name="TextBox 15"/>
+          <p:cNvSpPr txBox="1"/>
+          <p:nvPr/>
+        </p:nvSpPr>
+        <p:spPr>
+          <a:xfrm>
+            <a:off x="658368" y="3566160"/>
+            <a:ext cx="1828800" cy="164592"/>
+          </a:xfrm>
+          <a:prstGeom prst="rect">
+            <a:avLst/>
+          </a:prstGeom>
+          <a:noFill/>
+        </p:spPr>
+        <p:txBody>
+          <a:bodyPr wrap="square" lIns="45720" rIns="45720" tIns="18288" bIns="18288">
+            <a:spAutoFit/>
+          </a:bodyPr>
+          <a:lstStyle/>
+          <a:p>
+            <a:pPr algn="l"/>
+            <a:r>
+              <a:rPr sz="700" b="0">
+                <a:solidFill>
+                  <a:srgbClr val="773333"/>
+                </a:solidFill>
+                <a:latin typeface="Calibri"/>
+              </a:rPr>
+              <a:t>↕  switch app</a:t>
+            </a:r>
+          </a:p>
+        </p:txBody>
+      </p:sp>
+      <p:sp>
+        <p:nvSpPr>
+          <p:cNvPr id="17" name="Rectangle 16"/>
           <p:cNvSpPr/>
           <p:nvPr/>
         </p:nvSpPr>
         <p:spPr>
           <a:xfrm>
-            <a:off x="5440680" y="3429000"/>
-            <a:ext cx="1280160" cy="1280160"/>
-          </a:xfrm>
-          <a:prstGeom prst="ellipse">
+            <a:off x="548640" y="3639312"/>
+            <a:ext cx="4937760" cy="438912"/>
+          </a:xfrm>
+          <a:prstGeom prst="rect">
             <a:avLst/>
           </a:prstGeom>
           <a:solidFill>
-            <a:srgbClr val="FFC107"/>
+            <a:srgbClr val="201010"/>
           </a:solidFill>
-          <a:ln>
-            <a:noFill/>
+          <a:ln w="12700">
+            <a:solidFill>
+              <a:srgbClr val="552020"/>
+            </a:solidFill>
           </a:ln>
         </p:spPr>
         <p:style>
@@ -25269,90 +24966,1530 @@
       </p:sp>
       <p:sp>
         <p:nvSpPr>
-          <p:cNvPr id="13" name="TextBox 12"/>
-          <p:cNvSpPr txBox="1"/>
-          <p:nvPr/>
-        </p:nvSpPr>
-        <p:spPr>
-          <a:xfrm>
-            <a:off x="5440680" y="3593592"/>
-            <a:ext cx="1280160" cy="1280160"/>
-          </a:xfrm>
-          <a:prstGeom prst="rect">
-            <a:avLst/>
-          </a:prstGeom>
-          <a:noFill/>
-        </p:spPr>
-        <p:txBody>
-          <a:bodyPr wrap="square" lIns="45720" rIns="45720" tIns="18288" bIns="18288">
-            <a:spAutoFit/>
-          </a:bodyPr>
+          <p:cNvPr id="18" name="TextBox 17"/>
+          <p:cNvSpPr txBox="1"/>
+          <p:nvPr/>
+        </p:nvSpPr>
+        <p:spPr>
+          <a:xfrm>
+            <a:off x="658368" y="3675888"/>
+            <a:ext cx="2011680" cy="228600"/>
+          </a:xfrm>
+          <a:prstGeom prst="rect">
+            <a:avLst/>
+          </a:prstGeom>
+          <a:noFill/>
+        </p:spPr>
+        <p:txBody>
+          <a:bodyPr wrap="square" lIns="45720" rIns="45720" tIns="18288" bIns="18288">
+            <a:spAutoFit/>
+          </a:bodyPr>
+          <a:lstStyle/>
+          <a:p>
+            <a:pPr algn="l"/>
+            <a:r>
+              <a:rPr sz="1100" b="1">
+                <a:solidFill>
+                  <a:srgbClr val="FFFFFF"/>
+                </a:solidFill>
+                <a:latin typeface="Calibri"/>
+              </a:rPr>
+              <a:t>→  Take Notes</a:t>
+            </a:r>
+          </a:p>
+        </p:txBody>
+      </p:sp>
+      <p:sp>
+        <p:nvSpPr>
+          <p:cNvPr id="19" name="TextBox 18"/>
+          <p:cNvSpPr txBox="1"/>
+          <p:nvPr/>
+        </p:nvSpPr>
+        <p:spPr>
+          <a:xfrm>
+            <a:off x="658368" y="3877056"/>
+            <a:ext cx="2743200" cy="182880"/>
+          </a:xfrm>
+          <a:prstGeom prst="rect">
+            <a:avLst/>
+          </a:prstGeom>
+          <a:noFill/>
+        </p:spPr>
+        <p:txBody>
+          <a:bodyPr wrap="square" lIns="45720" rIns="45720" tIns="18288" bIns="18288">
+            <a:spAutoFit/>
+          </a:bodyPr>
+          <a:lstStyle/>
+          <a:p>
+            <a:pPr algn="l"/>
+            <a:r>
+              <a:rPr sz="800" b="0">
+                <a:solidFill>
+                  <a:srgbClr val="EF4444"/>
+                </a:solidFill>
+                <a:latin typeface="Calibri"/>
+              </a:rPr>
+              <a:t>Word, Notion, sticky notes</a:t>
+            </a:r>
+          </a:p>
+        </p:txBody>
+      </p:sp>
+      <p:sp>
+        <p:nvSpPr>
+          <p:cNvPr id="20" name="TextBox 19"/>
+          <p:cNvSpPr txBox="1"/>
+          <p:nvPr/>
+        </p:nvSpPr>
+        <p:spPr>
+          <a:xfrm>
+            <a:off x="658368" y="4096512"/>
+            <a:ext cx="1828800" cy="164592"/>
+          </a:xfrm>
+          <a:prstGeom prst="rect">
+            <a:avLst/>
+          </a:prstGeom>
+          <a:noFill/>
+        </p:spPr>
+        <p:txBody>
+          <a:bodyPr wrap="square" lIns="45720" rIns="45720" tIns="18288" bIns="18288">
+            <a:spAutoFit/>
+          </a:bodyPr>
+          <a:lstStyle/>
+          <a:p>
+            <a:pPr algn="l"/>
+            <a:r>
+              <a:rPr sz="700" b="0">
+                <a:solidFill>
+                  <a:srgbClr val="773333"/>
+                </a:solidFill>
+                <a:latin typeface="Calibri"/>
+              </a:rPr>
+              <a:t>↕  switch app</a:t>
+            </a:r>
+          </a:p>
+        </p:txBody>
+      </p:sp>
+      <p:sp>
+        <p:nvSpPr>
+          <p:cNvPr id="21" name="Rectangle 20"/>
+          <p:cNvSpPr/>
+          <p:nvPr/>
+        </p:nvSpPr>
+        <p:spPr>
+          <a:xfrm>
+            <a:off x="548640" y="4169663"/>
+            <a:ext cx="4937760" cy="438912"/>
+          </a:xfrm>
+          <a:prstGeom prst="rect">
+            <a:avLst/>
+          </a:prstGeom>
+          <a:solidFill>
+            <a:srgbClr val="201010"/>
+          </a:solidFill>
+          <a:ln w="12700">
+            <a:solidFill>
+              <a:srgbClr val="552020"/>
+            </a:solidFill>
+          </a:ln>
+        </p:spPr>
+        <p:style>
+          <a:lnRef idx="1">
+            <a:schemeClr val="accent1"/>
+          </a:lnRef>
+          <a:fillRef idx="3">
+            <a:schemeClr val="accent1"/>
+          </a:fillRef>
+          <a:effectRef idx="2">
+            <a:schemeClr val="accent1"/>
+          </a:effectRef>
+          <a:fontRef idx="minor">
+            <a:schemeClr val="lt1"/>
+          </a:fontRef>
+        </p:style>
+        <p:txBody>
+          <a:bodyPr rtlCol="0" anchor="ctr"/>
           <a:lstStyle/>
           <a:p>
             <a:pPr algn="ctr"/>
-            <a:r>
-              <a:rPr sz="5400" b="1">
-                <a:solidFill>
-                  <a:srgbClr val="0A0E1A"/>
-                </a:solidFill>
-                <a:latin typeface="Calibri"/>
-              </a:rPr>
-              <a:t>▶</a:t>
-            </a:r>
-          </a:p>
-        </p:txBody>
-      </p:sp>
-      <p:sp>
-        <p:nvSpPr>
-          <p:cNvPr id="14" name="TextBox 13"/>
-          <p:cNvSpPr txBox="1"/>
-          <p:nvPr/>
-        </p:nvSpPr>
-        <p:spPr>
-          <a:xfrm>
-            <a:off x="365760" y="5897880"/>
-            <a:ext cx="11430000" cy="292608"/>
-          </a:xfrm>
-          <a:prstGeom prst="rect">
-            <a:avLst/>
-          </a:prstGeom>
-          <a:noFill/>
-        </p:spPr>
-        <p:txBody>
-          <a:bodyPr wrap="square" lIns="45720" rIns="45720" tIns="18288" bIns="18288">
-            <a:spAutoFit/>
-          </a:bodyPr>
+          </a:p>
+        </p:txBody>
+      </p:sp>
+      <p:sp>
+        <p:nvSpPr>
+          <p:cNvPr id="22" name="TextBox 21"/>
+          <p:cNvSpPr txBox="1"/>
+          <p:nvPr/>
+        </p:nvSpPr>
+        <p:spPr>
+          <a:xfrm>
+            <a:off x="658368" y="4206239"/>
+            <a:ext cx="2011680" cy="228600"/>
+          </a:xfrm>
+          <a:prstGeom prst="rect">
+            <a:avLst/>
+          </a:prstGeom>
+          <a:noFill/>
+        </p:spPr>
+        <p:txBody>
+          <a:bodyPr wrap="square" lIns="45720" rIns="45720" tIns="18288" bIns="18288">
+            <a:spAutoFit/>
+          </a:bodyPr>
+          <a:lstStyle/>
+          <a:p>
+            <a:pPr algn="l"/>
+            <a:r>
+              <a:rPr sz="1100" b="1">
+                <a:solidFill>
+                  <a:srgbClr val="FFFFFF"/>
+                </a:solidFill>
+                <a:latin typeface="Calibri"/>
+              </a:rPr>
+              <a:t>→  Write Draft</a:t>
+            </a:r>
+          </a:p>
+        </p:txBody>
+      </p:sp>
+      <p:sp>
+        <p:nvSpPr>
+          <p:cNvPr id="23" name="TextBox 22"/>
+          <p:cNvSpPr txBox="1"/>
+          <p:nvPr/>
+        </p:nvSpPr>
+        <p:spPr>
+          <a:xfrm>
+            <a:off x="658368" y="4407407"/>
+            <a:ext cx="2743200" cy="182880"/>
+          </a:xfrm>
+          <a:prstGeom prst="rect">
+            <a:avLst/>
+          </a:prstGeom>
+          <a:noFill/>
+        </p:spPr>
+        <p:txBody>
+          <a:bodyPr wrap="square" lIns="45720" rIns="45720" tIns="18288" bIns="18288">
+            <a:spAutoFit/>
+          </a:bodyPr>
+          <a:lstStyle/>
+          <a:p>
+            <a:pPr algn="l"/>
+            <a:r>
+              <a:rPr sz="800" b="0">
+                <a:solidFill>
+                  <a:srgbClr val="EF4444"/>
+                </a:solidFill>
+                <a:latin typeface="Calibri"/>
+              </a:rPr>
+              <a:t>MS Word / Docs</a:t>
+            </a:r>
+          </a:p>
+        </p:txBody>
+      </p:sp>
+      <p:sp>
+        <p:nvSpPr>
+          <p:cNvPr id="24" name="TextBox 23"/>
+          <p:cNvSpPr txBox="1"/>
+          <p:nvPr/>
+        </p:nvSpPr>
+        <p:spPr>
+          <a:xfrm>
+            <a:off x="658368" y="4626863"/>
+            <a:ext cx="1828800" cy="164592"/>
+          </a:xfrm>
+          <a:prstGeom prst="rect">
+            <a:avLst/>
+          </a:prstGeom>
+          <a:noFill/>
+        </p:spPr>
+        <p:txBody>
+          <a:bodyPr wrap="square" lIns="45720" rIns="45720" tIns="18288" bIns="18288">
+            <a:spAutoFit/>
+          </a:bodyPr>
+          <a:lstStyle/>
+          <a:p>
+            <a:pPr algn="l"/>
+            <a:r>
+              <a:rPr sz="700" b="0">
+                <a:solidFill>
+                  <a:srgbClr val="773333"/>
+                </a:solidFill>
+                <a:latin typeface="Calibri"/>
+              </a:rPr>
+              <a:t>↕  switch app</a:t>
+            </a:r>
+          </a:p>
+        </p:txBody>
+      </p:sp>
+      <p:sp>
+        <p:nvSpPr>
+          <p:cNvPr id="25" name="Rectangle 24"/>
+          <p:cNvSpPr/>
+          <p:nvPr/>
+        </p:nvSpPr>
+        <p:spPr>
+          <a:xfrm>
+            <a:off x="548640" y="4700016"/>
+            <a:ext cx="4937760" cy="438912"/>
+          </a:xfrm>
+          <a:prstGeom prst="rect">
+            <a:avLst/>
+          </a:prstGeom>
+          <a:solidFill>
+            <a:srgbClr val="201010"/>
+          </a:solidFill>
+          <a:ln w="12700">
+            <a:solidFill>
+              <a:srgbClr val="552020"/>
+            </a:solidFill>
+          </a:ln>
+        </p:spPr>
+        <p:style>
+          <a:lnRef idx="1">
+            <a:schemeClr val="accent1"/>
+          </a:lnRef>
+          <a:fillRef idx="3">
+            <a:schemeClr val="accent1"/>
+          </a:fillRef>
+          <a:effectRef idx="2">
+            <a:schemeClr val="accent1"/>
+          </a:effectRef>
+          <a:fontRef idx="minor">
+            <a:schemeClr val="lt1"/>
+          </a:fontRef>
+        </p:style>
+        <p:txBody>
+          <a:bodyPr rtlCol="0" anchor="ctr"/>
           <a:lstStyle/>
           <a:p>
             <a:pPr algn="ctr"/>
+          </a:p>
+        </p:txBody>
+      </p:sp>
+      <p:sp>
+        <p:nvSpPr>
+          <p:cNvPr id="26" name="TextBox 25"/>
+          <p:cNvSpPr txBox="1"/>
+          <p:nvPr/>
+        </p:nvSpPr>
+        <p:spPr>
+          <a:xfrm>
+            <a:off x="658368" y="4736592"/>
+            <a:ext cx="2011680" cy="228600"/>
+          </a:xfrm>
+          <a:prstGeom prst="rect">
+            <a:avLst/>
+          </a:prstGeom>
+          <a:noFill/>
+        </p:spPr>
+        <p:txBody>
+          <a:bodyPr wrap="square" lIns="45720" rIns="45720" tIns="18288" bIns="18288">
+            <a:spAutoFit/>
+          </a:bodyPr>
+          <a:lstStyle/>
+          <a:p>
+            <a:pPr algn="l"/>
             <a:r>
               <a:rPr sz="1100" b="1">
                 <a:solidFill>
+                  <a:srgbClr val="FFFFFF"/>
+                </a:solidFill>
+                <a:latin typeface="Calibri"/>
+              </a:rPr>
+              <a:t>→  Generate Citations</a:t>
+            </a:r>
+          </a:p>
+        </p:txBody>
+      </p:sp>
+      <p:sp>
+        <p:nvSpPr>
+          <p:cNvPr id="27" name="TextBox 26"/>
+          <p:cNvSpPr txBox="1"/>
+          <p:nvPr/>
+        </p:nvSpPr>
+        <p:spPr>
+          <a:xfrm>
+            <a:off x="658368" y="4937760"/>
+            <a:ext cx="2743200" cy="182880"/>
+          </a:xfrm>
+          <a:prstGeom prst="rect">
+            <a:avLst/>
+          </a:prstGeom>
+          <a:noFill/>
+        </p:spPr>
+        <p:txBody>
+          <a:bodyPr wrap="square" lIns="45720" rIns="45720" tIns="18288" bIns="18288">
+            <a:spAutoFit/>
+          </a:bodyPr>
+          <a:lstStyle/>
+          <a:p>
+            <a:pPr algn="l"/>
+            <a:r>
+              <a:rPr sz="800" b="0">
+                <a:solidFill>
+                  <a:srgbClr val="EF4444"/>
+                </a:solidFill>
+                <a:latin typeface="Calibri"/>
+              </a:rPr>
+              <a:t>Zotero / Mendeley</a:t>
+            </a:r>
+          </a:p>
+        </p:txBody>
+      </p:sp>
+      <p:sp>
+        <p:nvSpPr>
+          <p:cNvPr id="28" name="TextBox 27"/>
+          <p:cNvSpPr txBox="1"/>
+          <p:nvPr/>
+        </p:nvSpPr>
+        <p:spPr>
+          <a:xfrm>
+            <a:off x="658368" y="5157216"/>
+            <a:ext cx="1828800" cy="164592"/>
+          </a:xfrm>
+          <a:prstGeom prst="rect">
+            <a:avLst/>
+          </a:prstGeom>
+          <a:noFill/>
+        </p:spPr>
+        <p:txBody>
+          <a:bodyPr wrap="square" lIns="45720" rIns="45720" tIns="18288" bIns="18288">
+            <a:spAutoFit/>
+          </a:bodyPr>
+          <a:lstStyle/>
+          <a:p>
+            <a:pPr algn="l"/>
+            <a:r>
+              <a:rPr sz="700" b="0">
+                <a:solidFill>
+                  <a:srgbClr val="773333"/>
+                </a:solidFill>
+                <a:latin typeface="Calibri"/>
+              </a:rPr>
+              <a:t>↕  switch app</a:t>
+            </a:r>
+          </a:p>
+        </p:txBody>
+      </p:sp>
+      <p:sp>
+        <p:nvSpPr>
+          <p:cNvPr id="29" name="Rectangle 28"/>
+          <p:cNvSpPr/>
+          <p:nvPr/>
+        </p:nvSpPr>
+        <p:spPr>
+          <a:xfrm>
+            <a:off x="548640" y="5230368"/>
+            <a:ext cx="4937760" cy="438912"/>
+          </a:xfrm>
+          <a:prstGeom prst="rect">
+            <a:avLst/>
+          </a:prstGeom>
+          <a:solidFill>
+            <a:srgbClr val="201010"/>
+          </a:solidFill>
+          <a:ln w="12700">
+            <a:solidFill>
+              <a:srgbClr val="552020"/>
+            </a:solidFill>
+          </a:ln>
+        </p:spPr>
+        <p:style>
+          <a:lnRef idx="1">
+            <a:schemeClr val="accent1"/>
+          </a:lnRef>
+          <a:fillRef idx="3">
+            <a:schemeClr val="accent1"/>
+          </a:fillRef>
+          <a:effectRef idx="2">
+            <a:schemeClr val="accent1"/>
+          </a:effectRef>
+          <a:fontRef idx="minor">
+            <a:schemeClr val="lt1"/>
+          </a:fontRef>
+        </p:style>
+        <p:txBody>
+          <a:bodyPr rtlCol="0" anchor="ctr"/>
+          <a:lstStyle/>
+          <a:p>
+            <a:pPr algn="ctr"/>
+          </a:p>
+        </p:txBody>
+      </p:sp>
+      <p:sp>
+        <p:nvSpPr>
+          <p:cNvPr id="30" name="TextBox 29"/>
+          <p:cNvSpPr txBox="1"/>
+          <p:nvPr/>
+        </p:nvSpPr>
+        <p:spPr>
+          <a:xfrm>
+            <a:off x="658368" y="5266944"/>
+            <a:ext cx="2011680" cy="228600"/>
+          </a:xfrm>
+          <a:prstGeom prst="rect">
+            <a:avLst/>
+          </a:prstGeom>
+          <a:noFill/>
+        </p:spPr>
+        <p:txBody>
+          <a:bodyPr wrap="square" lIns="45720" rIns="45720" tIns="18288" bIns="18288">
+            <a:spAutoFit/>
+          </a:bodyPr>
+          <a:lstStyle/>
+          <a:p>
+            <a:pPr algn="l"/>
+            <a:r>
+              <a:rPr sz="1100" b="1">
+                <a:solidFill>
+                  <a:srgbClr val="FFFFFF"/>
+                </a:solidFill>
+                <a:latin typeface="Calibri"/>
+              </a:rPr>
+              <a:t>→  Create Slides</a:t>
+            </a:r>
+          </a:p>
+        </p:txBody>
+      </p:sp>
+      <p:sp>
+        <p:nvSpPr>
+          <p:cNvPr id="31" name="TextBox 30"/>
+          <p:cNvSpPr txBox="1"/>
+          <p:nvPr/>
+        </p:nvSpPr>
+        <p:spPr>
+          <a:xfrm>
+            <a:off x="658368" y="5468112"/>
+            <a:ext cx="2743200" cy="182880"/>
+          </a:xfrm>
+          <a:prstGeom prst="rect">
+            <a:avLst/>
+          </a:prstGeom>
+          <a:noFill/>
+        </p:spPr>
+        <p:txBody>
+          <a:bodyPr wrap="square" lIns="45720" rIns="45720" tIns="18288" bIns="18288">
+            <a:spAutoFit/>
+          </a:bodyPr>
+          <a:lstStyle/>
+          <a:p>
+            <a:pPr algn="l"/>
+            <a:r>
+              <a:rPr sz="800" b="0">
+                <a:solidFill>
+                  <a:srgbClr val="EF4444"/>
+                </a:solidFill>
+                <a:latin typeface="Calibri"/>
+              </a:rPr>
+              <a:t>PowerPoint / Canva</a:t>
+            </a:r>
+          </a:p>
+        </p:txBody>
+      </p:sp>
+      <p:sp>
+        <p:nvSpPr>
+          <p:cNvPr id="32" name="TextBox 31"/>
+          <p:cNvSpPr txBox="1"/>
+          <p:nvPr/>
+        </p:nvSpPr>
+        <p:spPr>
+          <a:xfrm>
+            <a:off x="658368" y="5687568"/>
+            <a:ext cx="1828800" cy="164592"/>
+          </a:xfrm>
+          <a:prstGeom prst="rect">
+            <a:avLst/>
+          </a:prstGeom>
+          <a:noFill/>
+        </p:spPr>
+        <p:txBody>
+          <a:bodyPr wrap="square" lIns="45720" rIns="45720" tIns="18288" bIns="18288">
+            <a:spAutoFit/>
+          </a:bodyPr>
+          <a:lstStyle/>
+          <a:p>
+            <a:pPr algn="l"/>
+            <a:r>
+              <a:rPr sz="700" b="0">
+                <a:solidFill>
+                  <a:srgbClr val="773333"/>
+                </a:solidFill>
+                <a:latin typeface="Calibri"/>
+              </a:rPr>
+              <a:t>↕  switch app</a:t>
+            </a:r>
+          </a:p>
+        </p:txBody>
+      </p:sp>
+      <p:sp>
+        <p:nvSpPr>
+          <p:cNvPr id="33" name="Rectangle 32"/>
+          <p:cNvSpPr/>
+          <p:nvPr/>
+        </p:nvSpPr>
+        <p:spPr>
+          <a:xfrm>
+            <a:off x="548640" y="5760720"/>
+            <a:ext cx="4937760" cy="438912"/>
+          </a:xfrm>
+          <a:prstGeom prst="rect">
+            <a:avLst/>
+          </a:prstGeom>
+          <a:solidFill>
+            <a:srgbClr val="201010"/>
+          </a:solidFill>
+          <a:ln w="12700">
+            <a:solidFill>
+              <a:srgbClr val="552020"/>
+            </a:solidFill>
+          </a:ln>
+        </p:spPr>
+        <p:style>
+          <a:lnRef idx="1">
+            <a:schemeClr val="accent1"/>
+          </a:lnRef>
+          <a:fillRef idx="3">
+            <a:schemeClr val="accent1"/>
+          </a:fillRef>
+          <a:effectRef idx="2">
+            <a:schemeClr val="accent1"/>
+          </a:effectRef>
+          <a:fontRef idx="minor">
+            <a:schemeClr val="lt1"/>
+          </a:fontRef>
+        </p:style>
+        <p:txBody>
+          <a:bodyPr rtlCol="0" anchor="ctr"/>
+          <a:lstStyle/>
+          <a:p>
+            <a:pPr algn="ctr"/>
+          </a:p>
+        </p:txBody>
+      </p:sp>
+      <p:sp>
+        <p:nvSpPr>
+          <p:cNvPr id="34" name="TextBox 33"/>
+          <p:cNvSpPr txBox="1"/>
+          <p:nvPr/>
+        </p:nvSpPr>
+        <p:spPr>
+          <a:xfrm>
+            <a:off x="658368" y="5797296"/>
+            <a:ext cx="2011680" cy="228600"/>
+          </a:xfrm>
+          <a:prstGeom prst="rect">
+            <a:avLst/>
+          </a:prstGeom>
+          <a:noFill/>
+        </p:spPr>
+        <p:txBody>
+          <a:bodyPr wrap="square" lIns="45720" rIns="45720" tIns="18288" bIns="18288">
+            <a:spAutoFit/>
+          </a:bodyPr>
+          <a:lstStyle/>
+          <a:p>
+            <a:pPr algn="l"/>
+            <a:r>
+              <a:rPr sz="1100" b="1">
+                <a:solidFill>
+                  <a:srgbClr val="FFFFFF"/>
+                </a:solidFill>
+                <a:latin typeface="Calibri"/>
+              </a:rPr>
+              <a:t>→  Store Documents</a:t>
+            </a:r>
+          </a:p>
+        </p:txBody>
+      </p:sp>
+      <p:sp>
+        <p:nvSpPr>
+          <p:cNvPr id="35" name="TextBox 34"/>
+          <p:cNvSpPr txBox="1"/>
+          <p:nvPr/>
+        </p:nvSpPr>
+        <p:spPr>
+          <a:xfrm>
+            <a:off x="658368" y="5998464"/>
+            <a:ext cx="2743200" cy="182880"/>
+          </a:xfrm>
+          <a:prstGeom prst="rect">
+            <a:avLst/>
+          </a:prstGeom>
+          <a:noFill/>
+        </p:spPr>
+        <p:txBody>
+          <a:bodyPr wrap="square" lIns="45720" rIns="45720" tIns="18288" bIns="18288">
+            <a:spAutoFit/>
+          </a:bodyPr>
+          <a:lstStyle/>
+          <a:p>
+            <a:pPr algn="l"/>
+            <a:r>
+              <a:rPr sz="800" b="0">
+                <a:solidFill>
+                  <a:srgbClr val="EF4444"/>
+                </a:solidFill>
+                <a:latin typeface="Calibri"/>
+              </a:rPr>
+              <a:t>Drive / email to self</a:t>
+            </a:r>
+          </a:p>
+        </p:txBody>
+      </p:sp>
+      <p:sp>
+        <p:nvSpPr>
+          <p:cNvPr id="36" name="TextBox 35"/>
+          <p:cNvSpPr txBox="1"/>
+          <p:nvPr/>
+        </p:nvSpPr>
+        <p:spPr>
+          <a:xfrm>
+            <a:off x="5806440" y="4114800"/>
+            <a:ext cx="731520" cy="548640"/>
+          </a:xfrm>
+          <a:prstGeom prst="rect">
+            <a:avLst/>
+          </a:prstGeom>
+          <a:noFill/>
+        </p:spPr>
+        <p:txBody>
+          <a:bodyPr wrap="square" lIns="45720" rIns="45720" tIns="18288" bIns="18288">
+            <a:spAutoFit/>
+          </a:bodyPr>
+          <a:lstStyle/>
+          <a:p>
+            <a:pPr algn="ctr"/>
+            <a:r>
+              <a:rPr sz="3600" b="1">
+                <a:solidFill>
                   <a:srgbClr val="FFC107"/>
                 </a:solidFill>
                 <a:latin typeface="Calibri"/>
               </a:rPr>
-              <a:t>WATCH THE FULL DEMO</a:t>
-            </a:r>
-          </a:p>
-        </p:txBody>
-      </p:sp>
-      <p:sp>
-        <p:nvSpPr>
-          <p:cNvPr id="15" name="Rectangle 14"/>
+              <a:t>⟹</a:t>
+            </a:r>
+          </a:p>
+        </p:txBody>
+      </p:sp>
+      <p:sp>
+        <p:nvSpPr>
+          <p:cNvPr id="37" name="Rectangle 36"/>
           <p:cNvSpPr/>
           <p:nvPr/>
         </p:nvSpPr>
         <p:spPr>
           <a:xfrm>
-            <a:off x="3200400" y="6199632"/>
-            <a:ext cx="5760720" cy="320040"/>
+            <a:off x="6675120" y="2331720"/>
+            <a:ext cx="5303520" cy="4160520"/>
           </a:xfrm>
           <a:prstGeom prst="rect">
             <a:avLst/>
           </a:prstGeom>
           <a:solidFill>
-            <a:srgbClr val="121728"/>
+            <a:srgbClr val="06180C"/>
+          </a:solidFill>
+          <a:ln w="12700">
+            <a:solidFill>
+              <a:srgbClr val="22C55E"/>
+            </a:solidFill>
+          </a:ln>
+        </p:spPr>
+        <p:style>
+          <a:lnRef idx="1">
+            <a:schemeClr val="accent1"/>
+          </a:lnRef>
+          <a:fillRef idx="3">
+            <a:schemeClr val="accent1"/>
+          </a:fillRef>
+          <a:effectRef idx="2">
+            <a:schemeClr val="accent1"/>
+          </a:effectRef>
+          <a:fontRef idx="minor">
+            <a:schemeClr val="lt1"/>
+          </a:fontRef>
+        </p:style>
+        <p:txBody>
+          <a:bodyPr rtlCol="0" anchor="ctr"/>
+          <a:lstStyle/>
+          <a:p>
+            <a:pPr algn="ctr"/>
+          </a:p>
+        </p:txBody>
+      </p:sp>
+      <p:sp>
+        <p:nvSpPr>
+          <p:cNvPr id="38" name="TextBox 37"/>
+          <p:cNvSpPr txBox="1"/>
+          <p:nvPr/>
+        </p:nvSpPr>
+        <p:spPr>
+          <a:xfrm>
+            <a:off x="6858000" y="2468880"/>
+            <a:ext cx="5029200" cy="256032"/>
+          </a:xfrm>
+          <a:prstGeom prst="rect">
+            <a:avLst/>
+          </a:prstGeom>
+          <a:noFill/>
+        </p:spPr>
+        <p:txBody>
+          <a:bodyPr wrap="square" lIns="45720" rIns="45720" tIns="18288" bIns="18288">
+            <a:spAutoFit/>
+          </a:bodyPr>
+          <a:lstStyle/>
+          <a:p>
+            <a:pPr algn="l"/>
+            <a:r>
+              <a:rPr sz="900" b="1">
+                <a:solidFill>
+                  <a:srgbClr val="22C55E"/>
+                </a:solidFill>
+                <a:latin typeface="Calibri"/>
+              </a:rPr>
+              <a:t>✓  WITH DYNAMO AI</a:t>
+            </a:r>
+          </a:p>
+        </p:txBody>
+      </p:sp>
+      <p:sp>
+        <p:nvSpPr>
+          <p:cNvPr id="39" name="TextBox 38"/>
+          <p:cNvSpPr txBox="1"/>
+          <p:nvPr/>
+        </p:nvSpPr>
+        <p:spPr>
+          <a:xfrm>
+            <a:off x="6858000" y="2743200"/>
+            <a:ext cx="5029200" cy="256032"/>
+          </a:xfrm>
+          <a:prstGeom prst="rect">
+            <a:avLst/>
+          </a:prstGeom>
+          <a:noFill/>
+        </p:spPr>
+        <p:txBody>
+          <a:bodyPr wrap="square" lIns="45720" rIns="45720" tIns="18288" bIns="18288">
+            <a:spAutoFit/>
+          </a:bodyPr>
+          <a:lstStyle/>
+          <a:p>
+            <a:pPr algn="l"/>
+            <a:r>
+              <a:rPr sz="1000" b="0">
+                <a:solidFill>
+                  <a:srgbClr val="AAAABB"/>
+                </a:solidFill>
+                <a:latin typeface="Calibri"/>
+              </a:rPr>
+              <a:t>Single platform. Single workflow.</a:t>
+            </a:r>
+          </a:p>
+        </p:txBody>
+      </p:sp>
+      <p:sp>
+        <p:nvSpPr>
+          <p:cNvPr id="40" name="Rectangle 39"/>
+          <p:cNvSpPr/>
+          <p:nvPr/>
+        </p:nvSpPr>
+        <p:spPr>
+          <a:xfrm>
+            <a:off x="6858000" y="3108960"/>
+            <a:ext cx="4937760" cy="438912"/>
+          </a:xfrm>
+          <a:prstGeom prst="rect">
+            <a:avLst/>
+          </a:prstGeom>
+          <a:solidFill>
+            <a:srgbClr val="082210"/>
+          </a:solidFill>
+          <a:ln w="12700">
+            <a:solidFill>
+              <a:srgbClr val="185528"/>
+            </a:solidFill>
+          </a:ln>
+        </p:spPr>
+        <p:style>
+          <a:lnRef idx="1">
+            <a:schemeClr val="accent1"/>
+          </a:lnRef>
+          <a:fillRef idx="3">
+            <a:schemeClr val="accent1"/>
+          </a:fillRef>
+          <a:effectRef idx="2">
+            <a:schemeClr val="accent1"/>
+          </a:effectRef>
+          <a:fontRef idx="minor">
+            <a:schemeClr val="lt1"/>
+          </a:fontRef>
+        </p:style>
+        <p:txBody>
+          <a:bodyPr rtlCol="0" anchor="ctr"/>
+          <a:lstStyle/>
+          <a:p>
+            <a:pPr algn="ctr"/>
+          </a:p>
+        </p:txBody>
+      </p:sp>
+      <p:sp>
+        <p:nvSpPr>
+          <p:cNvPr id="41" name="TextBox 40"/>
+          <p:cNvSpPr txBox="1"/>
+          <p:nvPr/>
+        </p:nvSpPr>
+        <p:spPr>
+          <a:xfrm>
+            <a:off x="6967728" y="3145536"/>
+            <a:ext cx="2560320" cy="228600"/>
+          </a:xfrm>
+          <a:prstGeom prst="rect">
+            <a:avLst/>
+          </a:prstGeom>
+          <a:noFill/>
+        </p:spPr>
+        <p:txBody>
+          <a:bodyPr wrap="square" lIns="45720" rIns="45720" tIns="18288" bIns="18288">
+            <a:spAutoFit/>
+          </a:bodyPr>
+          <a:lstStyle/>
+          <a:p>
+            <a:pPr algn="l"/>
+            <a:r>
+              <a:rPr sz="1100" b="1">
+                <a:solidFill>
+                  <a:srgbClr val="FFFFFF"/>
+                </a:solidFill>
+                <a:latin typeface="Calibri"/>
+              </a:rPr>
+              <a:t>✓  Discover evidence-backed papers</a:t>
+            </a:r>
+          </a:p>
+        </p:txBody>
+      </p:sp>
+      <p:sp>
+        <p:nvSpPr>
+          <p:cNvPr id="42" name="TextBox 41"/>
+          <p:cNvSpPr txBox="1"/>
+          <p:nvPr/>
+        </p:nvSpPr>
+        <p:spPr>
+          <a:xfrm>
+            <a:off x="6967728" y="3346704"/>
+            <a:ext cx="2926080" cy="182880"/>
+          </a:xfrm>
+          <a:prstGeom prst="rect">
+            <a:avLst/>
+          </a:prstGeom>
+          <a:noFill/>
+        </p:spPr>
+        <p:txBody>
+          <a:bodyPr wrap="square" lIns="45720" rIns="45720" tIns="18288" bIns="18288">
+            <a:spAutoFit/>
+          </a:bodyPr>
+          <a:lstStyle/>
+          <a:p>
+            <a:pPr algn="l"/>
+            <a:r>
+              <a:rPr sz="800" b="0">
+                <a:solidFill>
+                  <a:srgbClr val="22C55E"/>
+                </a:solidFill>
+                <a:latin typeface="Calibri"/>
+              </a:rPr>
+              <a:t>Evidence-backed research assistance</a:t>
+            </a:r>
+          </a:p>
+        </p:txBody>
+      </p:sp>
+      <p:sp>
+        <p:nvSpPr>
+          <p:cNvPr id="43" name="Rectangle 42"/>
+          <p:cNvSpPr/>
+          <p:nvPr/>
+        </p:nvSpPr>
+        <p:spPr>
+          <a:xfrm>
+            <a:off x="6858000" y="3639312"/>
+            <a:ext cx="4937760" cy="438912"/>
+          </a:xfrm>
+          <a:prstGeom prst="rect">
+            <a:avLst/>
+          </a:prstGeom>
+          <a:solidFill>
+            <a:srgbClr val="082210"/>
+          </a:solidFill>
+          <a:ln w="12700">
+            <a:solidFill>
+              <a:srgbClr val="185528"/>
+            </a:solidFill>
+          </a:ln>
+        </p:spPr>
+        <p:style>
+          <a:lnRef idx="1">
+            <a:schemeClr val="accent1"/>
+          </a:lnRef>
+          <a:fillRef idx="3">
+            <a:schemeClr val="accent1"/>
+          </a:fillRef>
+          <a:effectRef idx="2">
+            <a:schemeClr val="accent1"/>
+          </a:effectRef>
+          <a:fontRef idx="minor">
+            <a:schemeClr val="lt1"/>
+          </a:fontRef>
+        </p:style>
+        <p:txBody>
+          <a:bodyPr rtlCol="0" anchor="ctr"/>
+          <a:lstStyle/>
+          <a:p>
+            <a:pPr algn="ctr"/>
+          </a:p>
+        </p:txBody>
+      </p:sp>
+      <p:sp>
+        <p:nvSpPr>
+          <p:cNvPr id="44" name="TextBox 43"/>
+          <p:cNvSpPr txBox="1"/>
+          <p:nvPr/>
+        </p:nvSpPr>
+        <p:spPr>
+          <a:xfrm>
+            <a:off x="6967728" y="3675888"/>
+            <a:ext cx="2560320" cy="228600"/>
+          </a:xfrm>
+          <a:prstGeom prst="rect">
+            <a:avLst/>
+          </a:prstGeom>
+          <a:noFill/>
+        </p:spPr>
+        <p:txBody>
+          <a:bodyPr wrap="square" lIns="45720" rIns="45720" tIns="18288" bIns="18288">
+            <a:spAutoFit/>
+          </a:bodyPr>
+          <a:lstStyle/>
+          <a:p>
+            <a:pPr algn="l"/>
+            <a:r>
+              <a:rPr sz="1100" b="1">
+                <a:solidFill>
+                  <a:srgbClr val="FFFFFF"/>
+                </a:solidFill>
+                <a:latin typeface="Calibri"/>
+              </a:rPr>
+              <a:t>✓  Analyse &amp; take smart notes</a:t>
+            </a:r>
+          </a:p>
+        </p:txBody>
+      </p:sp>
+      <p:sp>
+        <p:nvSpPr>
+          <p:cNvPr id="45" name="TextBox 44"/>
+          <p:cNvSpPr txBox="1"/>
+          <p:nvPr/>
+        </p:nvSpPr>
+        <p:spPr>
+          <a:xfrm>
+            <a:off x="6967728" y="3877056"/>
+            <a:ext cx="2926080" cy="182880"/>
+          </a:xfrm>
+          <a:prstGeom prst="rect">
+            <a:avLst/>
+          </a:prstGeom>
+          <a:noFill/>
+        </p:spPr>
+        <p:txBody>
+          <a:bodyPr wrap="square" lIns="45720" rIns="45720" tIns="18288" bIns="18288">
+            <a:spAutoFit/>
+          </a:bodyPr>
+          <a:lstStyle/>
+          <a:p>
+            <a:pPr algn="l"/>
+            <a:r>
+              <a:rPr sz="800" b="0">
+                <a:solidFill>
+                  <a:srgbClr val="22C55E"/>
+                </a:solidFill>
+                <a:latin typeface="Calibri"/>
+              </a:rPr>
+              <a:t>Insights, gaps and summaries — instant</a:t>
+            </a:r>
+          </a:p>
+        </p:txBody>
+      </p:sp>
+      <p:sp>
+        <p:nvSpPr>
+          <p:cNvPr id="46" name="Rectangle 45"/>
+          <p:cNvSpPr/>
+          <p:nvPr/>
+        </p:nvSpPr>
+        <p:spPr>
+          <a:xfrm>
+            <a:off x="6858000" y="4169663"/>
+            <a:ext cx="4937760" cy="438912"/>
+          </a:xfrm>
+          <a:prstGeom prst="rect">
+            <a:avLst/>
+          </a:prstGeom>
+          <a:solidFill>
+            <a:srgbClr val="082210"/>
+          </a:solidFill>
+          <a:ln w="12700">
+            <a:solidFill>
+              <a:srgbClr val="185528"/>
+            </a:solidFill>
+          </a:ln>
+        </p:spPr>
+        <p:style>
+          <a:lnRef idx="1">
+            <a:schemeClr val="accent1"/>
+          </a:lnRef>
+          <a:fillRef idx="3">
+            <a:schemeClr val="accent1"/>
+          </a:fillRef>
+          <a:effectRef idx="2">
+            <a:schemeClr val="accent1"/>
+          </a:effectRef>
+          <a:fontRef idx="minor">
+            <a:schemeClr val="lt1"/>
+          </a:fontRef>
+        </p:style>
+        <p:txBody>
+          <a:bodyPr rtlCol="0" anchor="ctr"/>
+          <a:lstStyle/>
+          <a:p>
+            <a:pPr algn="ctr"/>
+          </a:p>
+        </p:txBody>
+      </p:sp>
+      <p:sp>
+        <p:nvSpPr>
+          <p:cNvPr id="47" name="TextBox 46"/>
+          <p:cNvSpPr txBox="1"/>
+          <p:nvPr/>
+        </p:nvSpPr>
+        <p:spPr>
+          <a:xfrm>
+            <a:off x="6967728" y="4206239"/>
+            <a:ext cx="2560320" cy="228600"/>
+          </a:xfrm>
+          <a:prstGeom prst="rect">
+            <a:avLst/>
+          </a:prstGeom>
+          <a:noFill/>
+        </p:spPr>
+        <p:txBody>
+          <a:bodyPr wrap="square" lIns="45720" rIns="45720" tIns="18288" bIns="18288">
+            <a:spAutoFit/>
+          </a:bodyPr>
+          <a:lstStyle/>
+          <a:p>
+            <a:pPr algn="l"/>
+            <a:r>
+              <a:rPr sz="1100" b="1">
+                <a:solidFill>
+                  <a:srgbClr val="FFFFFF"/>
+                </a:solidFill>
+                <a:latin typeface="Calibri"/>
+              </a:rPr>
+              <a:t>✓  Draft academic content</a:t>
+            </a:r>
+          </a:p>
+        </p:txBody>
+      </p:sp>
+      <p:sp>
+        <p:nvSpPr>
+          <p:cNvPr id="48" name="TextBox 47"/>
+          <p:cNvSpPr txBox="1"/>
+          <p:nvPr/>
+        </p:nvSpPr>
+        <p:spPr>
+          <a:xfrm>
+            <a:off x="6967728" y="4407407"/>
+            <a:ext cx="2926080" cy="182880"/>
+          </a:xfrm>
+          <a:prstGeom prst="rect">
+            <a:avLst/>
+          </a:prstGeom>
+          <a:noFill/>
+        </p:spPr>
+        <p:txBody>
+          <a:bodyPr wrap="square" lIns="45720" rIns="45720" tIns="18288" bIns="18288">
+            <a:spAutoFit/>
+          </a:bodyPr>
+          <a:lstStyle/>
+          <a:p>
+            <a:pPr algn="l"/>
+            <a:r>
+              <a:rPr sz="800" b="0">
+                <a:solidFill>
+                  <a:srgbClr val="22C55E"/>
+                </a:solidFill>
+                <a:latin typeface="Calibri"/>
+              </a:rPr>
+              <a:t>Structured assistance with DeepThink AI</a:t>
+            </a:r>
+          </a:p>
+        </p:txBody>
+      </p:sp>
+      <p:sp>
+        <p:nvSpPr>
+          <p:cNvPr id="49" name="Rectangle 48"/>
+          <p:cNvSpPr/>
+          <p:nvPr/>
+        </p:nvSpPr>
+        <p:spPr>
+          <a:xfrm>
+            <a:off x="6858000" y="4700016"/>
+            <a:ext cx="4937760" cy="438912"/>
+          </a:xfrm>
+          <a:prstGeom prst="rect">
+            <a:avLst/>
+          </a:prstGeom>
+          <a:solidFill>
+            <a:srgbClr val="082210"/>
+          </a:solidFill>
+          <a:ln w="12700">
+            <a:solidFill>
+              <a:srgbClr val="185528"/>
+            </a:solidFill>
+          </a:ln>
+        </p:spPr>
+        <p:style>
+          <a:lnRef idx="1">
+            <a:schemeClr val="accent1"/>
+          </a:lnRef>
+          <a:fillRef idx="3">
+            <a:schemeClr val="accent1"/>
+          </a:fillRef>
+          <a:effectRef idx="2">
+            <a:schemeClr val="accent1"/>
+          </a:effectRef>
+          <a:fontRef idx="minor">
+            <a:schemeClr val="lt1"/>
+          </a:fontRef>
+        </p:style>
+        <p:txBody>
+          <a:bodyPr rtlCol="0" anchor="ctr"/>
+          <a:lstStyle/>
+          <a:p>
+            <a:pPr algn="ctr"/>
+          </a:p>
+        </p:txBody>
+      </p:sp>
+      <p:sp>
+        <p:nvSpPr>
+          <p:cNvPr id="50" name="TextBox 49"/>
+          <p:cNvSpPr txBox="1"/>
+          <p:nvPr/>
+        </p:nvSpPr>
+        <p:spPr>
+          <a:xfrm>
+            <a:off x="6967728" y="4736592"/>
+            <a:ext cx="2560320" cy="228600"/>
+          </a:xfrm>
+          <a:prstGeom prst="rect">
+            <a:avLst/>
+          </a:prstGeom>
+          <a:noFill/>
+        </p:spPr>
+        <p:txBody>
+          <a:bodyPr wrap="square" lIns="45720" rIns="45720" tIns="18288" bIns="18288">
+            <a:spAutoFit/>
+          </a:bodyPr>
+          <a:lstStyle/>
+          <a:p>
+            <a:pPr algn="l"/>
+            <a:r>
+              <a:rPr sz="1100" b="1">
+                <a:solidFill>
+                  <a:srgbClr val="FFFFFF"/>
+                </a:solidFill>
+                <a:latin typeface="Calibri"/>
+              </a:rPr>
+              <a:t>✓  Generate citations automatically</a:t>
+            </a:r>
+          </a:p>
+        </p:txBody>
+      </p:sp>
+      <p:sp>
+        <p:nvSpPr>
+          <p:cNvPr id="51" name="TextBox 50"/>
+          <p:cNvSpPr txBox="1"/>
+          <p:nvPr/>
+        </p:nvSpPr>
+        <p:spPr>
+          <a:xfrm>
+            <a:off x="6967728" y="4937760"/>
+            <a:ext cx="2926080" cy="182880"/>
+          </a:xfrm>
+          <a:prstGeom prst="rect">
+            <a:avLst/>
+          </a:prstGeom>
+          <a:noFill/>
+        </p:spPr>
+        <p:txBody>
+          <a:bodyPr wrap="square" lIns="45720" rIns="45720" tIns="18288" bIns="18288">
+            <a:spAutoFit/>
+          </a:bodyPr>
+          <a:lstStyle/>
+          <a:p>
+            <a:pPr algn="l"/>
+            <a:r>
+              <a:rPr sz="800" b="0">
+                <a:solidFill>
+                  <a:srgbClr val="22C55E"/>
+                </a:solidFill>
+                <a:latin typeface="Calibri"/>
+              </a:rPr>
+              <a:t>6 formats — APA, MLA, IEEE and more</a:t>
+            </a:r>
+          </a:p>
+        </p:txBody>
+      </p:sp>
+      <p:sp>
+        <p:nvSpPr>
+          <p:cNvPr id="52" name="Rectangle 51"/>
+          <p:cNvSpPr/>
+          <p:nvPr/>
+        </p:nvSpPr>
+        <p:spPr>
+          <a:xfrm>
+            <a:off x="6858000" y="5230368"/>
+            <a:ext cx="4937760" cy="438912"/>
+          </a:xfrm>
+          <a:prstGeom prst="rect">
+            <a:avLst/>
+          </a:prstGeom>
+          <a:solidFill>
+            <a:srgbClr val="082210"/>
+          </a:solidFill>
+          <a:ln w="12700">
+            <a:solidFill>
+              <a:srgbClr val="185528"/>
+            </a:solidFill>
+          </a:ln>
+        </p:spPr>
+        <p:style>
+          <a:lnRef idx="1">
+            <a:schemeClr val="accent1"/>
+          </a:lnRef>
+          <a:fillRef idx="3">
+            <a:schemeClr val="accent1"/>
+          </a:fillRef>
+          <a:effectRef idx="2">
+            <a:schemeClr val="accent1"/>
+          </a:effectRef>
+          <a:fontRef idx="minor">
+            <a:schemeClr val="lt1"/>
+          </a:fontRef>
+        </p:style>
+        <p:txBody>
+          <a:bodyPr rtlCol="0" anchor="ctr"/>
+          <a:lstStyle/>
+          <a:p>
+            <a:pPr algn="ctr"/>
+          </a:p>
+        </p:txBody>
+      </p:sp>
+      <p:sp>
+        <p:nvSpPr>
+          <p:cNvPr id="53" name="TextBox 52"/>
+          <p:cNvSpPr txBox="1"/>
+          <p:nvPr/>
+        </p:nvSpPr>
+        <p:spPr>
+          <a:xfrm>
+            <a:off x="6967728" y="5266944"/>
+            <a:ext cx="2560320" cy="228600"/>
+          </a:xfrm>
+          <a:prstGeom prst="rect">
+            <a:avLst/>
+          </a:prstGeom>
+          <a:noFill/>
+        </p:spPr>
+        <p:txBody>
+          <a:bodyPr wrap="square" lIns="45720" rIns="45720" tIns="18288" bIns="18288">
+            <a:spAutoFit/>
+          </a:bodyPr>
+          <a:lstStyle/>
+          <a:p>
+            <a:pPr algn="l"/>
+            <a:r>
+              <a:rPr sz="1100" b="1">
+                <a:solidFill>
+                  <a:srgbClr val="FFFFFF"/>
+                </a:solidFill>
+                <a:latin typeface="Calibri"/>
+              </a:rPr>
+              <a:t>✓  Convert research to a deck</a:t>
+            </a:r>
+          </a:p>
+        </p:txBody>
+      </p:sp>
+      <p:sp>
+        <p:nvSpPr>
+          <p:cNvPr id="54" name="TextBox 53"/>
+          <p:cNvSpPr txBox="1"/>
+          <p:nvPr/>
+        </p:nvSpPr>
+        <p:spPr>
+          <a:xfrm>
+            <a:off x="6967728" y="5468112"/>
+            <a:ext cx="2926080" cy="182880"/>
+          </a:xfrm>
+          <a:prstGeom prst="rect">
+            <a:avLst/>
+          </a:prstGeom>
+          <a:noFill/>
+        </p:spPr>
+        <p:txBody>
+          <a:bodyPr wrap="square" lIns="45720" rIns="45720" tIns="18288" bIns="18288">
+            <a:spAutoFit/>
+          </a:bodyPr>
+          <a:lstStyle/>
+          <a:p>
+            <a:pPr algn="l"/>
+            <a:r>
+              <a:rPr sz="800" b="0">
+                <a:solidFill>
+                  <a:srgbClr val="22C55E"/>
+                </a:solidFill>
+                <a:latin typeface="Calibri"/>
+              </a:rPr>
+              <a:t>Slides, mindmaps, flowcharts — in seconds</a:t>
+            </a:r>
+          </a:p>
+        </p:txBody>
+      </p:sp>
+      <p:sp>
+        <p:nvSpPr>
+          <p:cNvPr id="55" name="Rectangle 54"/>
+          <p:cNvSpPr/>
+          <p:nvPr/>
+        </p:nvSpPr>
+        <p:spPr>
+          <a:xfrm>
+            <a:off x="6858000" y="5760720"/>
+            <a:ext cx="4937760" cy="438912"/>
+          </a:xfrm>
+          <a:prstGeom prst="rect">
+            <a:avLst/>
+          </a:prstGeom>
+          <a:solidFill>
+            <a:srgbClr val="082210"/>
+          </a:solidFill>
+          <a:ln w="12700">
+            <a:solidFill>
+              <a:srgbClr val="185528"/>
+            </a:solidFill>
+          </a:ln>
+        </p:spPr>
+        <p:style>
+          <a:lnRef idx="1">
+            <a:schemeClr val="accent1"/>
+          </a:lnRef>
+          <a:fillRef idx="3">
+            <a:schemeClr val="accent1"/>
+          </a:fillRef>
+          <a:effectRef idx="2">
+            <a:schemeClr val="accent1"/>
+          </a:effectRef>
+          <a:fontRef idx="minor">
+            <a:schemeClr val="lt1"/>
+          </a:fontRef>
+        </p:style>
+        <p:txBody>
+          <a:bodyPr rtlCol="0" anchor="ctr"/>
+          <a:lstStyle/>
+          <a:p>
+            <a:pPr algn="ctr"/>
+          </a:p>
+        </p:txBody>
+      </p:sp>
+      <p:sp>
+        <p:nvSpPr>
+          <p:cNvPr id="56" name="TextBox 55"/>
+          <p:cNvSpPr txBox="1"/>
+          <p:nvPr/>
+        </p:nvSpPr>
+        <p:spPr>
+          <a:xfrm>
+            <a:off x="6967728" y="5797296"/>
+            <a:ext cx="2560320" cy="228600"/>
+          </a:xfrm>
+          <a:prstGeom prst="rect">
+            <a:avLst/>
+          </a:prstGeom>
+          <a:noFill/>
+        </p:spPr>
+        <p:txBody>
+          <a:bodyPr wrap="square" lIns="45720" rIns="45720" tIns="18288" bIns="18288">
+            <a:spAutoFit/>
+          </a:bodyPr>
+          <a:lstStyle/>
+          <a:p>
+            <a:pPr algn="l"/>
+            <a:r>
+              <a:rPr sz="1100" b="1">
+                <a:solidFill>
+                  <a:srgbClr val="FFFFFF"/>
+                </a:solidFill>
+                <a:latin typeface="Calibri"/>
+              </a:rPr>
+              <a:t>✓  Store in Document Library</a:t>
+            </a:r>
+          </a:p>
+        </p:txBody>
+      </p:sp>
+      <p:sp>
+        <p:nvSpPr>
+          <p:cNvPr id="57" name="TextBox 56"/>
+          <p:cNvSpPr txBox="1"/>
+          <p:nvPr/>
+        </p:nvSpPr>
+        <p:spPr>
+          <a:xfrm>
+            <a:off x="6967728" y="5998464"/>
+            <a:ext cx="2926080" cy="182880"/>
+          </a:xfrm>
+          <a:prstGeom prst="rect">
+            <a:avLst/>
+          </a:prstGeom>
+          <a:noFill/>
+        </p:spPr>
+        <p:txBody>
+          <a:bodyPr wrap="square" lIns="45720" rIns="45720" tIns="18288" bIns="18288">
+            <a:spAutoFit/>
+          </a:bodyPr>
+          <a:lstStyle/>
+          <a:p>
+            <a:pPr algn="l"/>
+            <a:r>
+              <a:rPr sz="800" b="0">
+                <a:solidFill>
+                  <a:srgbClr val="22C55E"/>
+                </a:solidFill>
+                <a:latin typeface="Calibri"/>
+              </a:rPr>
+              <a:t>Access all research materials in one place</a:t>
+            </a:r>
+          </a:p>
+        </p:txBody>
+      </p:sp>
+      <p:sp>
+        <p:nvSpPr>
+          <p:cNvPr id="58" name="Rectangle 57"/>
+          <p:cNvSpPr/>
+          <p:nvPr/>
+        </p:nvSpPr>
+        <p:spPr>
+          <a:xfrm>
+            <a:off x="365760" y="6565392"/>
+            <a:ext cx="11430000" cy="182880"/>
+          </a:xfrm>
+          <a:prstGeom prst="rect">
+            <a:avLst/>
+          </a:prstGeom>
+          <a:solidFill>
+            <a:srgbClr val="181400"/>
           </a:solidFill>
           <a:ln w="12700">
             <a:solidFill>
@@ -25384,14 +26521,14 @@
       </p:sp>
       <p:sp>
         <p:nvSpPr>
-          <p:cNvPr id="16" name="TextBox 15"/>
-          <p:cNvSpPr txBox="1"/>
-          <p:nvPr/>
-        </p:nvSpPr>
-        <p:spPr>
-          <a:xfrm>
-            <a:off x="3246120" y="6236208"/>
-            <a:ext cx="5669280" cy="274320"/>
+          <p:cNvPr id="59" name="TextBox 58"/>
+          <p:cNvSpPr txBox="1"/>
+          <p:nvPr/>
+        </p:nvSpPr>
+        <p:spPr>
+          <a:xfrm>
+            <a:off x="548640" y="6583680"/>
+            <a:ext cx="11064240" cy="164592"/>
           </a:xfrm>
           <a:prstGeom prst="rect">
             <a:avLst/>
@@ -25406,48 +26543,83 @@
           <a:p>
             <a:pPr algn="ctr"/>
             <a:r>
-              <a:rPr sz="1200" b="1">
-                <a:solidFill>
-                  <a:srgbClr val="FFFFFF"/>
-                </a:solidFill>
-                <a:latin typeface="Calibri"/>
-              </a:rPr>
-              <a:t>▶  youtube.com/watch?v=YOUR_VIDEO_ID</a:t>
-            </a:r>
-          </a:p>
-        </p:txBody>
-      </p:sp>
-      <p:sp>
-        <p:nvSpPr>
-          <p:cNvPr id="17" name="TextBox 16"/>
-          <p:cNvSpPr txBox="1"/>
-          <p:nvPr/>
-        </p:nvSpPr>
-        <p:spPr>
-          <a:xfrm>
-            <a:off x="365760" y="6565392"/>
-            <a:ext cx="11430000" cy="201168"/>
-          </a:xfrm>
-          <a:prstGeom prst="rect">
-            <a:avLst/>
-          </a:prstGeom>
-          <a:noFill/>
-        </p:spPr>
-        <p:txBody>
-          <a:bodyPr wrap="square" lIns="45720" rIns="45720" tIns="18288" bIns="18288">
-            <a:spAutoFit/>
-          </a:bodyPr>
-          <a:lstStyle/>
-          <a:p>
-            <a:pPr algn="ctr"/>
-            <a:r>
-              <a:rPr sz="700" b="0">
-                <a:solidFill>
-                  <a:srgbClr val="555566"/>
-                </a:solidFill>
-                <a:latin typeface="Calibri"/>
-              </a:rPr>
-              <a:t>[ Founder: replace placeholder URL with your unlisted YouTube demo link before submission ]</a:t>
+              <a:rPr sz="900" b="1">
+                <a:solidFill>
+                  <a:srgbClr val="FFC107"/>
+                </a:solidFill>
+                <a:latin typeface="Calibri"/>
+              </a:rPr>
+              <a:t>Dynamo AI is not another AI chatbot. It is the academic workflow platform where researchers do all their work.</a:t>
+            </a:r>
+          </a:p>
+        </p:txBody>
+      </p:sp>
+      <p:sp>
+        <p:nvSpPr>
+          <p:cNvPr id="60" name="TextBox 59"/>
+          <p:cNvSpPr txBox="1"/>
+          <p:nvPr/>
+        </p:nvSpPr>
+        <p:spPr>
+          <a:xfrm>
+            <a:off x="365760" y="6492240"/>
+            <a:ext cx="3657600" cy="256032"/>
+          </a:xfrm>
+          <a:prstGeom prst="rect">
+            <a:avLst/>
+          </a:prstGeom>
+          <a:noFill/>
+        </p:spPr>
+        <p:txBody>
+          <a:bodyPr wrap="square" lIns="45720" rIns="45720" tIns="18288" bIns="18288">
+            <a:spAutoFit/>
+          </a:bodyPr>
+          <a:lstStyle/>
+          <a:p>
+            <a:pPr algn="l"/>
+            <a:r>
+              <a:rPr sz="800" b="0">
+                <a:solidFill>
+                  <a:srgbClr val="AAAABB"/>
+                </a:solidFill>
+                <a:latin typeface="Calibri"/>
+              </a:rPr>
+              <a:t>DYNAMO AI · CONFIDENTIAL</a:t>
+            </a:r>
+          </a:p>
+        </p:txBody>
+      </p:sp>
+      <p:sp>
+        <p:nvSpPr>
+          <p:cNvPr id="61" name="TextBox 60"/>
+          <p:cNvSpPr txBox="1"/>
+          <p:nvPr/>
+        </p:nvSpPr>
+        <p:spPr>
+          <a:xfrm>
+            <a:off x="8686800" y="6492240"/>
+            <a:ext cx="3108960" cy="256032"/>
+          </a:xfrm>
+          <a:prstGeom prst="rect">
+            <a:avLst/>
+          </a:prstGeom>
+          <a:noFill/>
+        </p:spPr>
+        <p:txBody>
+          <a:bodyPr wrap="square" lIns="45720" rIns="45720" tIns="18288" bIns="18288">
+            <a:spAutoFit/>
+          </a:bodyPr>
+          <a:lstStyle/>
+          <a:p>
+            <a:pPr algn="r"/>
+            <a:r>
+              <a:rPr sz="800" b="0">
+                <a:solidFill>
+                  <a:srgbClr val="AAAABB"/>
+                </a:solidFill>
+                <a:latin typeface="Calibri"/>
+              </a:rPr>
+              <a:t>app.dynamoai.in</a:t>
             </a:r>
           </a:p>
         </p:txBody>
@@ -25567,7 +26739,7 @@
                 </a:solidFill>
                 <a:latin typeface="Calibri"/>
               </a:rPr>
-              <a:t>WHY DYNAMO WINS</a:t>
+              <a:t>WHY RESEARCHERS CHOOSE DYNAMO AI</a:t>
             </a:r>
           </a:p>
         </p:txBody>
@@ -25616,7 +26788,7 @@
         <p:spPr>
           <a:xfrm>
             <a:off x="365760" y="868680"/>
-            <a:ext cx="1874519" cy="274320"/>
+            <a:ext cx="3584448" cy="274320"/>
           </a:xfrm>
           <a:prstGeom prst="rect">
             <a:avLst/>
@@ -25661,7 +26833,7 @@
         <p:spPr>
           <a:xfrm>
             <a:off x="411480" y="877824"/>
-            <a:ext cx="1783080" cy="256032"/>
+            <a:ext cx="3493008" cy="256032"/>
           </a:xfrm>
           <a:prstGeom prst="rect">
             <a:avLst/>
@@ -25682,7 +26854,7 @@
                 </a:solidFill>
                 <a:latin typeface="Calibri"/>
               </a:rPr>
-              <a:t>● WHY DYNAMO WINS</a:t>
+              <a:t>● WHY RESEARCHERS CHOOSE DYNAMO AI</a:t>
             </a:r>
           </a:p>
         </p:txBody>
@@ -25717,7 +26889,7 @@
                 </a:solidFill>
                 <a:latin typeface="Calibri"/>
               </a:rPr>
-              <a:t>Five reasons we win this category.</a:t>
+              <a:t>Why researchers choose Dynamo AI.</a:t>
             </a:r>
           </a:p>
         </p:txBody>
@@ -25731,7 +26903,7 @@
         <p:spPr>
           <a:xfrm>
             <a:off x="365760" y="1920240"/>
-            <a:ext cx="10058400" cy="365760"/>
+            <a:ext cx="10972800" cy="365760"/>
           </a:xfrm>
           <a:prstGeom prst="rect">
             <a:avLst/>
@@ -25752,7 +26924,7 @@
                 </a:solidFill>
                 <a:latin typeface="Calibri"/>
               </a:rPr>
-              <a:t>We're not another generic chatbot. Every design decision serves one user: the researcher.</a:t>
+              <a:t>Dynamo AI is not another AI chatbot. It is the academic workflow platform where researchers do all their work.</a:t>
             </a:r>
           </a:p>
         </p:txBody>
@@ -26167,7 +27339,7 @@
                 </a:solidFill>
                 <a:latin typeface="Calibri"/>
               </a:rPr>
-              <a:t>Persistent Academic Memory</a:t>
+              <a:t>Academic Memory Layer</a:t>
             </a:r>
           </a:p>
         </p:txBody>
@@ -26202,7 +27374,7 @@
                 </a:solidFill>
                 <a:latin typeface="Calibri"/>
               </a:rPr>
-              <a:t>AI Memory + Document Library give Dynamo lasting context about your work — no other academic AI does both.</a:t>
+              <a:t>Research context remains available across sessions, projects and uploaded documents — automatically, without any manual effort.</a:t>
             </a:r>
           </a:p>
         </p:txBody>
@@ -26282,7 +27454,7 @@
                 </a:solidFill>
                 <a:latin typeface="Calibri"/>
               </a:rPr>
-              <a:t>🇮🇳</a:t>
+              <a:t>📋</a:t>
             </a:r>
           </a:p>
         </p:txBody>
@@ -26317,7 +27489,7 @@
                 </a:solidFill>
                 <a:latin typeface="Calibri"/>
               </a:rPr>
-              <a:t>India-First Pricing &amp; Product</a:t>
+              <a:t>Generate publication-ready citations automatically</a:t>
             </a:r>
           </a:p>
         </p:txBody>
@@ -26352,7 +27524,7 @@
                 </a:solidFill>
                 <a:latin typeface="Calibri"/>
               </a:rPr>
-              <a:t>Designed for Indian researchers. INR pricing (₹399 / ₹999), local payment rails (Razorpay), Hindi roadmap.</a:t>
+              <a:t>6 academic citation formats, structured assistance, and evidence-backed research in one place.</a:t>
             </a:r>
           </a:p>
         </p:txBody>
@@ -26502,7 +27674,7 @@
                 </a:solidFill>
                 <a:latin typeface="Calibri"/>
               </a:rPr>
-              <a:t>Founder is a former data scientist who built Dynamo to solve a problem he experienced first-hand.</a:t>
+              <a:t>Founder is a data scientist who built Dynamo to solve a workflow problem he experienced first-hand.</a:t>
             </a:r>
           </a:p>
         </p:txBody>

</xml_diff>